<commit_message>
Redesigned UI, fix watcher double-ingest, refreshed screenshots and deck
- New UI: overview dashboard (KPIs, debt ring, incident/fix timeline), suggested
  questions, clear 'not in your records' state, visual block/rank/judge pipeline,
  policy lanes, audit chain view, toasts. Still one self-contained HTML file, works offline.
- Fix: demo drops and uploads were ingested twice (API + folder watcher race);
  the path is now claimed before the file is written. Regression test added.
- Screenshots and presentation updated to the new UI.

Co-Authored-By: Claude Opus 5.5 <noreply@anthropic.com>
</commit_message>
<xml_diff>
--- a/docs/RootCause-ASYNC26-Final.pptx
+++ b/docs/RootCause-ASYNC26-Final.pptx
@@ -17296,7 +17296,7 @@
                 <a:cs typeface="Arimo Bold"/>
                 <a:sym typeface="Arimo Bold"/>
               </a:rPr>
-              <a:t xml:space="preserve">A new incident links itself: block → rank → judge</a:t>
+              <a:t xml:space="preserve">Overview: top failure debt and fixes that did not hold</a:t>
             </a:r>
           </a:p>
         </p:txBody>
@@ -17368,7 +17368,7 @@
                 <a:cs typeface="Arimo Bold"/>
                 <a:sym typeface="Arimo Bold"/>
               </a:rPr>
-              <a:t xml:space="preserve">WHY THIS? — every link is inspectable</a:t>
+              <a:t xml:space="preserve">A new incident links itself: block → rank → judge</a:t>
             </a:r>
           </a:p>
         </p:txBody>
@@ -17440,7 +17440,7 @@
                 <a:cs typeface="Arimo Bold"/>
                 <a:sym typeface="Arimo Bold"/>
               </a:rPr>
-              <a:t xml:space="preserve">Failure debt and graded predictions</a:t>
+              <a:t xml:space="preserve">WHY THIS? — every link is inspectable</a:t>
             </a:r>
           </a:p>
         </p:txBody>
@@ -17663,7 +17663,7 @@
       </p:sp>
       <p:pic>
         <p:nvPicPr>
-          <p:cNvPr id="115" name="Picture 114" descr="02-live-ingest-links-cluster.png"/>
+          <p:cNvPr id="115" name="Picture 114" descr="00-overview.png"/>
           <p:cNvPicPr>
             <a:picLocks noChangeAspect="1"/>
           </p:cNvPicPr>
@@ -17688,7 +17688,7 @@
       </p:pic>
       <p:pic>
         <p:nvPicPr>
-          <p:cNvPr id="116" name="Picture 115" descr="03-why-this-evidence.png"/>
+          <p:cNvPr id="116" name="Picture 115" descr="02-live-ingest-links-cluster.png"/>
           <p:cNvPicPr>
             <a:picLocks noChangeAspect="1"/>
           </p:cNvPicPr>
@@ -17713,7 +17713,7 @@
       </p:pic>
       <p:pic>
         <p:nvPicPr>
-          <p:cNvPr id="117" name="Picture 116" descr="05-failure-debt-and-predictions.png"/>
+          <p:cNvPr id="117" name="Picture 116" descr="03-why-this-evidence.png"/>
           <p:cNvPicPr>
             <a:picLocks noChangeAspect="1"/>
           </p:cNvPicPr>

</xml_diff>

<commit_message>
Presentation: dashboard hero slide with callouts, four demo close-ups
Replaces the unreadable 6-thumbnail grid with a full-size annotated overview
and four high-resolution crops (WHY, pre-flight, policy/injection, audit).
scripts/deck_shots.py regenerates the captures.

Co-Authored-By: Claude Opus 5.5 <noreply@anthropic.com>
</commit_message>
<xml_diff>
--- a/docs/RootCause-ASYNC26-Final.pptx
+++ b/docs/RootCause-ASYNC26-Final.pptx
@@ -13,6 +13,7 @@
     <p:sldId id="261" r:id="rId10"/>
     <p:sldId id="262" r:id="rId11"/>
     <p:sldId id="263" r:id="rId12"/>
+    <p:sldId id="264" r:id="rId13"/>
   </p:sldIdLst>
   <p:sldSz cy="10287000" cx="18288000"/>
   <p:notesSz cx="6858000" cy="9144000"/>
@@ -17178,7 +17179,7 @@
                 <a:cs typeface="Arimo Bold"/>
                 <a:sym typeface="Arimo Bold"/>
               </a:rPr>
-              <a:t xml:space="preserve">Working prototype</a:t>
+              <a:t xml:space="preserve">The dashboard</a:t>
             </a:r>
           </a:p>
         </p:txBody>
@@ -17224,25 +17225,25 @@
                 <a:cs typeface="Arimo"/>
                 <a:sym typeface="Arimo"/>
               </a:rPr>
-              <a:t xml:space="preserve">Screens from the running system. Captured here in fallback mode; on the RTX 3050 it runs Llama 3.2 3B.</a:t>
-            </a:r>
-          </a:p>
-        </p:txBody>
-      </p:sp>
-      <p:sp>
-        <p:nvSpPr>
-          <p:cNvPr name="Card 103" id="103"/>
+              <a:t xml:space="preserve">One screen shows which failures keep returning, and which fixes never held.</a:t>
+            </a:r>
+          </a:p>
+        </p:txBody>
+      </p:sp>
+      <p:sp>
+        <p:nvSpPr>
+          <p:cNvPr name="Frame7" id="103"/>
           <p:cNvSpPr/>
           <p:nvPr/>
         </p:nvSpPr>
         <p:spPr>
           <a:xfrm>
-            <a:off x="996696" y="3218688"/>
-            <a:ext cx="5230368" cy="2670048"/>
+            <a:off x="722376" y="3218688"/>
+            <a:ext cx="9678010" cy="6089904"/>
           </a:xfrm>
           <a:prstGeom prst="roundRect">
             <a:avLst>
-              <a:gd name="adj" fmla="val 3424"/>
+              <a:gd name="adj" fmla="val 1801"/>
             </a:avLst>
           </a:prstGeom>
           <a:solidFill>
@@ -17255,16 +17256,88 @@
           <a:p/>
         </p:txBody>
       </p:sp>
-      <p:sp>
-        <p:nvSpPr>
-          <p:cNvPr name="Text 104" id="104"/>
-          <p:cNvSpPr txBox="true"/>
-          <p:nvPr/>
-        </p:nvSpPr>
-        <p:spPr>
-          <a:xfrm>
-            <a:off x="1051560" y="5943600"/>
-            <a:ext cx="5120640" cy="274320"/>
+      <p:pic>
+        <p:nvPicPr>
+          <p:cNvPr id="137" name="Picture 136" descr="deck-overview.jpg"/>
+          <p:cNvPicPr>
+            <a:picLocks noChangeAspect="1"/>
+          </p:cNvPicPr>
+          <p:nvPr/>
+        </p:nvPicPr>
+        <p:blipFill>
+          <a:blip r:embed="rId6"/>
+          <a:stretch>
+            <a:fillRect/>
+          </a:stretch>
+        </p:blipFill>
+        <p:spPr>
+          <a:xfrm>
+            <a:off x="777240" y="3273552"/>
+            <a:ext cx="9568282" cy="5980176"/>
+          </a:xfrm>
+          <a:prstGeom prst="rect">
+            <a:avLst/>
+          </a:prstGeom>
+        </p:spPr>
+      </p:pic>
+      <p:sp>
+        <p:nvSpPr>
+          <p:cNvPr name="Dot 104" id="104"/>
+          <p:cNvSpPr/>
+          <p:nvPr/>
+        </p:nvSpPr>
+        <p:spPr>
+          <a:xfrm>
+            <a:off x="2123895" y="3615538"/>
+            <a:ext cx="512064" cy="512064"/>
+          </a:xfrm>
+          <a:prstGeom prst="ellipse">
+            <a:avLst/>
+          </a:prstGeom>
+          <a:solidFill>
+            <a:srgbClr val="FFFFFF"/>
+          </a:solidFill>
+        </p:spPr>
+        <p:txBody>
+          <a:bodyPr/>
+          <a:lstStyle/>
+          <a:p/>
+        </p:txBody>
+      </p:sp>
+      <p:sp>
+        <p:nvSpPr>
+          <p:cNvPr name="Dot 105" id="105"/>
+          <p:cNvSpPr/>
+          <p:nvPr/>
+        </p:nvSpPr>
+        <p:spPr>
+          <a:xfrm>
+            <a:off x="2169615" y="3661258"/>
+            <a:ext cx="420624" cy="420624"/>
+          </a:xfrm>
+          <a:prstGeom prst="ellipse">
+            <a:avLst/>
+          </a:prstGeom>
+          <a:solidFill>
+            <a:srgbClr val="8B5CF6"/>
+          </a:solidFill>
+        </p:spPr>
+        <p:txBody>
+          <a:bodyPr/>
+          <a:lstStyle/>
+          <a:p/>
+        </p:txBody>
+      </p:sp>
+      <p:sp>
+        <p:nvSpPr>
+          <p:cNvPr name="Text 106" id="106"/>
+          <p:cNvSpPr txBox="true"/>
+          <p:nvPr/>
+        </p:nvSpPr>
+        <p:spPr>
+          <a:xfrm>
+            <a:off x="2169615" y="3745382"/>
+            <a:ext cx="420624" cy="252374"/>
           </a:xfrm>
           <a:prstGeom prst="rect">
             <a:avLst/>
@@ -17277,7 +17350,7 @@
           </a:bodyPr>
           <a:lstStyle/>
           <a:p>
-            <a:pPr algn="l">
+            <a:pPr algn="ctr">
               <a:lnSpc>
                 <a:spcPts val="1800"/>
               </a:lnSpc>
@@ -17287,38 +17360,36 @@
               <a:buNone/>
             </a:pPr>
             <a:r>
-              <a:rPr lang="en-US" b="true" sz="1500">
-                <a:solidFill>
-                  <a:srgbClr val="D7E3F2"/>
+              <a:rPr lang="en-US" b="true" sz="1800">
+                <a:solidFill>
+                  <a:srgbClr val="FFFFFF"/>
                 </a:solidFill>
                 <a:latin typeface="Arimo Bold"/>
                 <a:ea typeface="Arimo Bold"/>
                 <a:cs typeface="Arimo Bold"/>
                 <a:sym typeface="Arimo Bold"/>
               </a:rPr>
-              <a:t xml:space="preserve">Overview: top failure debt and fixes that did not hold</a:t>
-            </a:r>
-          </a:p>
-        </p:txBody>
-      </p:sp>
-      <p:sp>
-        <p:nvSpPr>
-          <p:cNvPr name="Card 105" id="105"/>
+              <a:t xml:space="preserve">1</a:t>
+            </a:r>
+          </a:p>
+        </p:txBody>
+      </p:sp>
+      <p:sp>
+        <p:nvSpPr>
+          <p:cNvPr name="Dot 107" id="107"/>
           <p:cNvSpPr/>
           <p:nvPr/>
         </p:nvSpPr>
         <p:spPr>
           <a:xfrm>
-            <a:off x="6528816" y="3218688"/>
-            <a:ext cx="5230368" cy="2670048"/>
-          </a:xfrm>
-          <a:prstGeom prst="roundRect">
-            <a:avLst>
-              <a:gd name="adj" fmla="val 3424"/>
-            </a:avLst>
+            <a:off x="6190415" y="4488643"/>
+            <a:ext cx="512064" cy="512064"/>
+          </a:xfrm>
+          <a:prstGeom prst="ellipse">
+            <a:avLst/>
           </a:prstGeom>
           <a:solidFill>
-            <a:srgbClr val="1B2437"/>
+            <a:srgbClr val="FFFFFF"/>
           </a:solidFill>
         </p:spPr>
         <p:txBody>
@@ -17329,14 +17400,38 @@
       </p:sp>
       <p:sp>
         <p:nvSpPr>
-          <p:cNvPr name="Text 106" id="106"/>
-          <p:cNvSpPr txBox="true"/>
-          <p:nvPr/>
-        </p:nvSpPr>
-        <p:spPr>
-          <a:xfrm>
-            <a:off x="6583680" y="5943600"/>
-            <a:ext cx="5120640" cy="274320"/>
+          <p:cNvPr name="Dot 108" id="108"/>
+          <p:cNvSpPr/>
+          <p:nvPr/>
+        </p:nvSpPr>
+        <p:spPr>
+          <a:xfrm>
+            <a:off x="6236135" y="4534363"/>
+            <a:ext cx="420624" cy="420624"/>
+          </a:xfrm>
+          <a:prstGeom prst="ellipse">
+            <a:avLst/>
+          </a:prstGeom>
+          <a:solidFill>
+            <a:srgbClr val="8B5CF6"/>
+          </a:solidFill>
+        </p:spPr>
+        <p:txBody>
+          <a:bodyPr/>
+          <a:lstStyle/>
+          <a:p/>
+        </p:txBody>
+      </p:sp>
+      <p:sp>
+        <p:nvSpPr>
+          <p:cNvPr name="Text 109" id="109"/>
+          <p:cNvSpPr txBox="true"/>
+          <p:nvPr/>
+        </p:nvSpPr>
+        <p:spPr>
+          <a:xfrm>
+            <a:off x="6236135" y="4618488"/>
+            <a:ext cx="420624" cy="252374"/>
           </a:xfrm>
           <a:prstGeom prst="rect">
             <a:avLst/>
@@ -17349,7 +17444,7 @@
           </a:bodyPr>
           <a:lstStyle/>
           <a:p>
-            <a:pPr algn="l">
+            <a:pPr algn="ctr">
               <a:lnSpc>
                 <a:spcPts val="1800"/>
               </a:lnSpc>
@@ -17359,38 +17454,36 @@
               <a:buNone/>
             </a:pPr>
             <a:r>
-              <a:rPr lang="en-US" b="true" sz="1500">
-                <a:solidFill>
-                  <a:srgbClr val="D7E3F2"/>
+              <a:rPr lang="en-US" b="true" sz="1800">
+                <a:solidFill>
+                  <a:srgbClr val="FFFFFF"/>
                 </a:solidFill>
                 <a:latin typeface="Arimo Bold"/>
                 <a:ea typeface="Arimo Bold"/>
                 <a:cs typeface="Arimo Bold"/>
                 <a:sym typeface="Arimo Bold"/>
               </a:rPr>
-              <a:t xml:space="preserve">A new incident links itself: block → rank → judge</a:t>
-            </a:r>
-          </a:p>
-        </p:txBody>
-      </p:sp>
-      <p:sp>
-        <p:nvSpPr>
-          <p:cNvPr name="Card 107" id="107"/>
+              <a:t xml:space="preserve">2</a:t>
+            </a:r>
+          </a:p>
+        </p:txBody>
+      </p:sp>
+      <p:sp>
+        <p:nvSpPr>
+          <p:cNvPr name="Dot 110" id="110"/>
           <p:cNvSpPr/>
           <p:nvPr/>
         </p:nvSpPr>
         <p:spPr>
           <a:xfrm>
-            <a:off x="12060936" y="3218688"/>
-            <a:ext cx="5230368" cy="2670048"/>
-          </a:xfrm>
-          <a:prstGeom prst="roundRect">
-            <a:avLst>
-              <a:gd name="adj" fmla="val 3424"/>
-            </a:avLst>
+            <a:off x="2321241" y="5571055"/>
+            <a:ext cx="512064" cy="512064"/>
+          </a:xfrm>
+          <a:prstGeom prst="ellipse">
+            <a:avLst/>
           </a:prstGeom>
           <a:solidFill>
-            <a:srgbClr val="1B2437"/>
+            <a:srgbClr val="FFFFFF"/>
           </a:solidFill>
         </p:spPr>
         <p:txBody>
@@ -17401,14 +17494,38 @@
       </p:sp>
       <p:sp>
         <p:nvSpPr>
-          <p:cNvPr name="Text 108" id="108"/>
-          <p:cNvSpPr txBox="true"/>
-          <p:nvPr/>
-        </p:nvSpPr>
-        <p:spPr>
-          <a:xfrm>
-            <a:off x="12115800" y="5943600"/>
-            <a:ext cx="5120640" cy="274320"/>
+          <p:cNvPr name="Dot 111" id="111"/>
+          <p:cNvSpPr/>
+          <p:nvPr/>
+        </p:nvSpPr>
+        <p:spPr>
+          <a:xfrm>
+            <a:off x="2366961" y="5616775"/>
+            <a:ext cx="420624" cy="420624"/>
+          </a:xfrm>
+          <a:prstGeom prst="ellipse">
+            <a:avLst/>
+          </a:prstGeom>
+          <a:solidFill>
+            <a:srgbClr val="8B5CF6"/>
+          </a:solidFill>
+        </p:spPr>
+        <p:txBody>
+          <a:bodyPr/>
+          <a:lstStyle/>
+          <a:p/>
+        </p:txBody>
+      </p:sp>
+      <p:sp>
+        <p:nvSpPr>
+          <p:cNvPr name="Text 112" id="112"/>
+          <p:cNvSpPr txBox="true"/>
+          <p:nvPr/>
+        </p:nvSpPr>
+        <p:spPr>
+          <a:xfrm>
+            <a:off x="2366961" y="5700900"/>
+            <a:ext cx="420624" cy="252374"/>
           </a:xfrm>
           <a:prstGeom prst="rect">
             <a:avLst/>
@@ -17421,7 +17538,7 @@
           </a:bodyPr>
           <a:lstStyle/>
           <a:p>
-            <a:pPr algn="l">
+            <a:pPr algn="ctr">
               <a:lnSpc>
                 <a:spcPts val="1800"/>
               </a:lnSpc>
@@ -17431,38 +17548,36 @@
               <a:buNone/>
             </a:pPr>
             <a:r>
-              <a:rPr lang="en-US" b="true" sz="1500">
-                <a:solidFill>
-                  <a:srgbClr val="D7E3F2"/>
+              <a:rPr lang="en-US" b="true" sz="1800">
+                <a:solidFill>
+                  <a:srgbClr val="FFFFFF"/>
                 </a:solidFill>
                 <a:latin typeface="Arimo Bold"/>
                 <a:ea typeface="Arimo Bold"/>
                 <a:cs typeface="Arimo Bold"/>
                 <a:sym typeface="Arimo Bold"/>
               </a:rPr>
-              <a:t xml:space="preserve">WHY THIS? — every link is inspectable</a:t>
-            </a:r>
-          </a:p>
-        </p:txBody>
-      </p:sp>
-      <p:sp>
-        <p:nvSpPr>
-          <p:cNvPr name="Card 109" id="109"/>
+              <a:t xml:space="preserve">3</a:t>
+            </a:r>
+          </a:p>
+        </p:txBody>
+      </p:sp>
+      <p:sp>
+        <p:nvSpPr>
+          <p:cNvPr name="Dot 113" id="113"/>
           <p:cNvSpPr/>
           <p:nvPr/>
         </p:nvSpPr>
         <p:spPr>
           <a:xfrm>
-            <a:off x="996696" y="6309360"/>
-            <a:ext cx="5230368" cy="2670048"/>
-          </a:xfrm>
-          <a:prstGeom prst="roundRect">
-            <a:avLst>
-              <a:gd name="adj" fmla="val 3424"/>
-            </a:avLst>
+            <a:off x="7015679" y="5230185"/>
+            <a:ext cx="512064" cy="512064"/>
+          </a:xfrm>
+          <a:prstGeom prst="ellipse">
+            <a:avLst/>
           </a:prstGeom>
           <a:solidFill>
-            <a:srgbClr val="1B2437"/>
+            <a:srgbClr val="FFFFFF"/>
           </a:solidFill>
         </p:spPr>
         <p:txBody>
@@ -17473,14 +17588,38 @@
       </p:sp>
       <p:sp>
         <p:nvSpPr>
-          <p:cNvPr name="Text 110" id="110"/>
-          <p:cNvSpPr txBox="true"/>
-          <p:nvPr/>
-        </p:nvSpPr>
-        <p:spPr>
-          <a:xfrm>
-            <a:off x="1051560" y="9034272"/>
-            <a:ext cx="5120640" cy="274320"/>
+          <p:cNvPr name="Dot 114" id="114"/>
+          <p:cNvSpPr/>
+          <p:nvPr/>
+        </p:nvSpPr>
+        <p:spPr>
+          <a:xfrm>
+            <a:off x="7061399" y="5275905"/>
+            <a:ext cx="420624" cy="420624"/>
+          </a:xfrm>
+          <a:prstGeom prst="ellipse">
+            <a:avLst/>
+          </a:prstGeom>
+          <a:solidFill>
+            <a:srgbClr val="8B5CF6"/>
+          </a:solidFill>
+        </p:spPr>
+        <p:txBody>
+          <a:bodyPr/>
+          <a:lstStyle/>
+          <a:p/>
+        </p:txBody>
+      </p:sp>
+      <p:sp>
+        <p:nvSpPr>
+          <p:cNvPr name="Text 115" id="115"/>
+          <p:cNvSpPr txBox="true"/>
+          <p:nvPr/>
+        </p:nvSpPr>
+        <p:spPr>
+          <a:xfrm>
+            <a:off x="7061399" y="5360030"/>
+            <a:ext cx="420624" cy="252374"/>
           </a:xfrm>
           <a:prstGeom prst="rect">
             <a:avLst/>
@@ -17493,7 +17632,7 @@
           </a:bodyPr>
           <a:lstStyle/>
           <a:p>
-            <a:pPr algn="l">
+            <a:pPr algn="ctr">
               <a:lnSpc>
                 <a:spcPts val="1800"/>
               </a:lnSpc>
@@ -17503,38 +17642,38 @@
               <a:buNone/>
             </a:pPr>
             <a:r>
-              <a:rPr lang="en-US" b="true" sz="1500">
-                <a:solidFill>
-                  <a:srgbClr val="D7E3F2"/>
+              <a:rPr lang="en-US" b="true" sz="1800">
+                <a:solidFill>
+                  <a:srgbClr val="FFFFFF"/>
                 </a:solidFill>
                 <a:latin typeface="Arimo Bold"/>
                 <a:ea typeface="Arimo Bold"/>
                 <a:cs typeface="Arimo Bold"/>
                 <a:sym typeface="Arimo Bold"/>
               </a:rPr>
-              <a:t xml:space="preserve">Pre-flight warning before the change ships</a:t>
-            </a:r>
-          </a:p>
-        </p:txBody>
-      </p:sp>
-      <p:sp>
-        <p:nvSpPr>
-          <p:cNvPr name="Card 111" id="111"/>
+              <a:t xml:space="preserve">4</a:t>
+            </a:r>
+          </a:p>
+        </p:txBody>
+      </p:sp>
+      <p:sp>
+        <p:nvSpPr>
+          <p:cNvPr name="Card 116" id="116"/>
           <p:cNvSpPr/>
           <p:nvPr/>
         </p:nvSpPr>
         <p:spPr>
           <a:xfrm>
-            <a:off x="6528816" y="6309360"/>
-            <a:ext cx="5230368" cy="2670048"/>
+            <a:off x="10711282" y="3273552"/>
+            <a:ext cx="6799478" cy="1252728"/>
           </a:xfrm>
           <a:prstGeom prst="roundRect">
             <a:avLst>
-              <a:gd name="adj" fmla="val 3424"/>
+              <a:gd name="adj" fmla="val 10218"/>
             </a:avLst>
           </a:prstGeom>
           <a:solidFill>
-            <a:srgbClr val="1B2437"/>
+            <a:srgbClr val="161F31"/>
           </a:solidFill>
         </p:spPr>
         <p:txBody>
@@ -17545,14 +17684,38 @@
       </p:sp>
       <p:sp>
         <p:nvSpPr>
-          <p:cNvPr name="Text 112" id="112"/>
-          <p:cNvSpPr txBox="true"/>
-          <p:nvPr/>
-        </p:nvSpPr>
-        <p:spPr>
-          <a:xfrm>
-            <a:off x="6583680" y="9034272"/>
-            <a:ext cx="5120640" cy="274320"/>
+          <p:cNvPr name="Dot 117" id="117"/>
+          <p:cNvSpPr/>
+          <p:nvPr/>
+        </p:nvSpPr>
+        <p:spPr>
+          <a:xfrm>
+            <a:off x="10985602" y="3547872"/>
+            <a:ext cx="420624" cy="420624"/>
+          </a:xfrm>
+          <a:prstGeom prst="ellipse">
+            <a:avLst/>
+          </a:prstGeom>
+          <a:solidFill>
+            <a:srgbClr val="8B5CF6"/>
+          </a:solidFill>
+        </p:spPr>
+        <p:txBody>
+          <a:bodyPr/>
+          <a:lstStyle/>
+          <a:p/>
+        </p:txBody>
+      </p:sp>
+      <p:sp>
+        <p:nvSpPr>
+          <p:cNvPr name="Text 118" id="118"/>
+          <p:cNvSpPr txBox="true"/>
+          <p:nvPr/>
+        </p:nvSpPr>
+        <p:spPr>
+          <a:xfrm>
+            <a:off x="10985602" y="3631997"/>
+            <a:ext cx="420624" cy="252374"/>
           </a:xfrm>
           <a:prstGeom prst="rect">
             <a:avLst/>
@@ -17565,7 +17728,7 @@
           </a:bodyPr>
           <a:lstStyle/>
           <a:p>
-            <a:pPr algn="l">
+            <a:pPr algn="ctr">
               <a:lnSpc>
                 <a:spcPts val="1800"/>
               </a:lnSpc>
@@ -17575,56 +17738,30 @@
               <a:buNone/>
             </a:pPr>
             <a:r>
-              <a:rPr lang="en-US" b="true" sz="1500">
-                <a:solidFill>
-                  <a:srgbClr val="D7E3F2"/>
+              <a:rPr lang="en-US" b="true" sz="1800">
+                <a:solidFill>
+                  <a:srgbClr val="FFFFFF"/>
                 </a:solidFill>
                 <a:latin typeface="Arimo Bold"/>
                 <a:ea typeface="Arimo Bold"/>
                 <a:cs typeface="Arimo Bold"/>
                 <a:sym typeface="Arimo Bold"/>
               </a:rPr>
-              <a:t xml:space="preserve">Poisoned document quarantined</a:t>
-            </a:r>
-          </a:p>
-        </p:txBody>
-      </p:sp>
-      <p:sp>
-        <p:nvSpPr>
-          <p:cNvPr name="Card 113" id="113"/>
-          <p:cNvSpPr/>
-          <p:nvPr/>
-        </p:nvSpPr>
-        <p:spPr>
-          <a:xfrm>
-            <a:off x="12060936" y="6309360"/>
-            <a:ext cx="5230368" cy="2670048"/>
-          </a:xfrm>
-          <a:prstGeom prst="roundRect">
-            <a:avLst>
-              <a:gd name="adj" fmla="val 3424"/>
-            </a:avLst>
-          </a:prstGeom>
-          <a:solidFill>
-            <a:srgbClr val="1B2437"/>
-          </a:solidFill>
-        </p:spPr>
-        <p:txBody>
-          <a:bodyPr/>
-          <a:lstStyle/>
-          <a:p/>
-        </p:txBody>
-      </p:sp>
-      <p:sp>
-        <p:nvSpPr>
-          <p:cNvPr name="Text 114" id="114"/>
-          <p:cNvSpPr txBox="true"/>
-          <p:nvPr/>
-        </p:nvSpPr>
-        <p:spPr>
-          <a:xfrm>
-            <a:off x="12115800" y="9034272"/>
-            <a:ext cx="5120640" cy="274320"/>
+              <a:t xml:space="preserve">1</a:t>
+            </a:r>
+          </a:p>
+        </p:txBody>
+      </p:sp>
+      <p:sp>
+        <p:nvSpPr>
+          <p:cNvPr name="Text 119" id="119"/>
+          <p:cNvSpPr txBox="true"/>
+          <p:nvPr/>
+        </p:nvSpPr>
+        <p:spPr>
+          <a:xfrm>
+            <a:off x="11607394" y="3547872"/>
+            <a:ext cx="5647334" cy="292608"/>
           </a:xfrm>
           <a:prstGeom prst="rect">
             <a:avLst/>
@@ -17639,7 +17776,7 @@
           <a:p>
             <a:pPr algn="l">
               <a:lnSpc>
-                <a:spcPts val="1800"/>
+                <a:spcPts val="2185"/>
               </a:lnSpc>
               <a:spcBef>
                 <a:spcPts val="0"/>
@@ -17647,170 +17784,676 @@
               <a:buNone/>
             </a:pPr>
             <a:r>
-              <a:rPr lang="en-US" b="true" sz="1500">
-                <a:solidFill>
-                  <a:srgbClr val="D7E3F2"/>
+              <a:rPr lang="en-US" b="true" sz="1900">
+                <a:solidFill>
+                  <a:srgbClr val="F4F7FF"/>
                 </a:solidFill>
                 <a:latin typeface="Arimo Bold"/>
                 <a:ea typeface="Arimo Bold"/>
                 <a:cs typeface="Arimo Bold"/>
                 <a:sym typeface="Arimo Bold"/>
               </a:rPr>
-              <a:t xml:space="preserve">A tampered ledger entry is detected</a:t>
-            </a:r>
-          </a:p>
-        </p:txBody>
-      </p:sp>
-      <p:pic>
-        <p:nvPicPr>
-          <p:cNvPr id="115" name="Picture 114" descr="00-overview.png"/>
-          <p:cNvPicPr>
-            <a:picLocks noChangeAspect="1"/>
-          </p:cNvPicPr>
-          <p:nvPr/>
-        </p:nvPicPr>
-        <p:blipFill>
-          <a:blip r:embed="rId6"/>
-          <a:srcRect b="20000"/>
-          <a:stretch>
-            <a:fillRect/>
-          </a:stretch>
-        </p:blipFill>
-        <p:spPr>
-          <a:xfrm>
-            <a:off x="1051560" y="3273552"/>
-            <a:ext cx="5120640" cy="2560320"/>
-          </a:xfrm>
-          <a:prstGeom prst="rect">
-            <a:avLst/>
-          </a:prstGeom>
-        </p:spPr>
-      </p:pic>
-      <p:pic>
-        <p:nvPicPr>
-          <p:cNvPr id="116" name="Picture 115" descr="02-live-ingest-links-cluster.png"/>
-          <p:cNvPicPr>
-            <a:picLocks noChangeAspect="1"/>
-          </p:cNvPicPr>
-          <p:nvPr/>
-        </p:nvPicPr>
-        <p:blipFill>
-          <a:blip r:embed="rId7"/>
-          <a:srcRect b="20000"/>
-          <a:stretch>
-            <a:fillRect/>
-          </a:stretch>
-        </p:blipFill>
-        <p:spPr>
-          <a:xfrm>
-            <a:off x="6583680" y="3273552"/>
-            <a:ext cx="5120640" cy="2560320"/>
-          </a:xfrm>
-          <a:prstGeom prst="rect">
-            <a:avLst/>
-          </a:prstGeom>
-        </p:spPr>
-      </p:pic>
-      <p:pic>
-        <p:nvPicPr>
-          <p:cNvPr id="117" name="Picture 116" descr="03-why-this-evidence.png"/>
-          <p:cNvPicPr>
-            <a:picLocks noChangeAspect="1"/>
-          </p:cNvPicPr>
-          <p:nvPr/>
-        </p:nvPicPr>
-        <p:blipFill>
-          <a:blip r:embed="rId8"/>
-          <a:srcRect b="20000"/>
-          <a:stretch>
-            <a:fillRect/>
-          </a:stretch>
-        </p:blipFill>
-        <p:spPr>
-          <a:xfrm>
-            <a:off x="12115800" y="3273552"/>
-            <a:ext cx="5120640" cy="2560320"/>
-          </a:xfrm>
-          <a:prstGeom prst="rect">
-            <a:avLst/>
-          </a:prstGeom>
-        </p:spPr>
-      </p:pic>
-      <p:pic>
-        <p:nvPicPr>
-          <p:cNvPr id="118" name="Picture 117" descr="06-preflight-warning.png"/>
-          <p:cNvPicPr>
-            <a:picLocks noChangeAspect="1"/>
-          </p:cNvPicPr>
-          <p:nvPr/>
-        </p:nvPicPr>
-        <p:blipFill>
-          <a:blip r:embed="rId9"/>
-          <a:srcRect b="20000"/>
-          <a:stretch>
-            <a:fillRect/>
-          </a:stretch>
-        </p:blipFill>
-        <p:spPr>
-          <a:xfrm>
-            <a:off x="1051560" y="6364224"/>
-            <a:ext cx="5120640" cy="2560320"/>
-          </a:xfrm>
-          <a:prstGeom prst="rect">
-            <a:avLst/>
-          </a:prstGeom>
-        </p:spPr>
-      </p:pic>
-      <p:pic>
-        <p:nvPicPr>
-          <p:cNvPr id="119" name="Picture 118" descr="07-prompt-injection-quarantined.png"/>
-          <p:cNvPicPr>
-            <a:picLocks noChangeAspect="1"/>
-          </p:cNvPicPr>
-          <p:nvPr/>
-        </p:nvPicPr>
-        <p:blipFill>
-          <a:blip r:embed="rId10"/>
-          <a:srcRect b="20000"/>
-          <a:stretch>
-            <a:fillRect/>
-          </a:stretch>
-        </p:blipFill>
-        <p:spPr>
-          <a:xfrm>
-            <a:off x="6583680" y="6364224"/>
-            <a:ext cx="5120640" cy="2560320"/>
-          </a:xfrm>
-          <a:prstGeom prst="rect">
-            <a:avLst/>
-          </a:prstGeom>
-        </p:spPr>
-      </p:pic>
-      <p:pic>
-        <p:nvPicPr>
-          <p:cNvPr id="120" name="Picture 119" descr="10-audit-tamper-detected.png"/>
-          <p:cNvPicPr>
-            <a:picLocks noChangeAspect="1"/>
-          </p:cNvPicPr>
-          <p:nvPr/>
-        </p:nvPicPr>
-        <p:blipFill>
-          <a:blip r:embed="rId11"/>
-          <a:srcRect b="20000"/>
-          <a:stretch>
-            <a:fillRect/>
-          </a:stretch>
-        </p:blipFill>
-        <p:spPr>
-          <a:xfrm>
-            <a:off x="12115800" y="6364224"/>
-            <a:ext cx="5120640" cy="2560320"/>
-          </a:xfrm>
-          <a:prstGeom prst="rect">
-            <a:avLst/>
-          </a:prstGeom>
-        </p:spPr>
-      </p:pic>
+              <a:t xml:space="preserve">Live counters</a:t>
+            </a:r>
+          </a:p>
+        </p:txBody>
+      </p:sp>
+      <p:sp>
+        <p:nvSpPr>
+          <p:cNvPr name="Text 120" id="120"/>
+          <p:cNvSpPr txBox="true"/>
+          <p:nvPr/>
+        </p:nvSpPr>
+        <p:spPr>
+          <a:xfrm>
+            <a:off x="11607394" y="3877056"/>
+            <a:ext cx="5647334" cy="539496"/>
+          </a:xfrm>
+          <a:prstGeom prst="rect">
+            <a:avLst/>
+          </a:prstGeom>
+          <a:noFill/>
+        </p:spPr>
+        <p:txBody>
+          <a:bodyPr anchor="t" wrap="square" rtlCol="false" tIns="0" lIns="0" bIns="0" rIns="0">
+            <a:noAutofit/>
+          </a:bodyPr>
+          <a:lstStyle/>
+          <a:p>
+            <a:pPr algn="l">
+              <a:lnSpc>
+                <a:spcPts val="1920"/>
+              </a:lnSpc>
+              <a:spcBef>
+                <a:spcPts val="0"/>
+              </a:spcBef>
+              <a:buNone/>
+            </a:pPr>
+            <a:r>
+              <a:rPr lang="en-US" sz="1500">
+                <a:solidFill>
+                  <a:srgbClr val="D7E3F2"/>
+                </a:solidFill>
+                <a:latin typeface="Arimo"/>
+                <a:ea typeface="Arimo"/>
+                <a:cs typeface="Arimo"/>
+                <a:sym typeface="Arimo"/>
+              </a:rPr>
+              <a:t xml:space="preserve">Documents, incidents, clusters, fixes that didn't hold, and external connections, which stays at zero.</a:t>
+            </a:r>
+          </a:p>
+        </p:txBody>
+      </p:sp>
+      <p:sp>
+        <p:nvSpPr>
+          <p:cNvPr name="Card 121" id="121"/>
+          <p:cNvSpPr/>
+          <p:nvPr/>
+        </p:nvSpPr>
+        <p:spPr>
+          <a:xfrm>
+            <a:off x="10711282" y="4709160"/>
+            <a:ext cx="6799478" cy="1252728"/>
+          </a:xfrm>
+          <a:prstGeom prst="roundRect">
+            <a:avLst>
+              <a:gd name="adj" fmla="val 10218"/>
+            </a:avLst>
+          </a:prstGeom>
+          <a:solidFill>
+            <a:srgbClr val="161F31"/>
+          </a:solidFill>
+        </p:spPr>
+        <p:txBody>
+          <a:bodyPr/>
+          <a:lstStyle/>
+          <a:p/>
+        </p:txBody>
+      </p:sp>
+      <p:sp>
+        <p:nvSpPr>
+          <p:cNvPr name="Dot 122" id="122"/>
+          <p:cNvSpPr/>
+          <p:nvPr/>
+        </p:nvSpPr>
+        <p:spPr>
+          <a:xfrm>
+            <a:off x="10985602" y="4983480"/>
+            <a:ext cx="420624" cy="420624"/>
+          </a:xfrm>
+          <a:prstGeom prst="ellipse">
+            <a:avLst/>
+          </a:prstGeom>
+          <a:solidFill>
+            <a:srgbClr val="8B5CF6"/>
+          </a:solidFill>
+        </p:spPr>
+        <p:txBody>
+          <a:bodyPr/>
+          <a:lstStyle/>
+          <a:p/>
+        </p:txBody>
+      </p:sp>
+      <p:sp>
+        <p:nvSpPr>
+          <p:cNvPr name="Text 123" id="123"/>
+          <p:cNvSpPr txBox="true"/>
+          <p:nvPr/>
+        </p:nvSpPr>
+        <p:spPr>
+          <a:xfrm>
+            <a:off x="10985602" y="5067605"/>
+            <a:ext cx="420624" cy="252374"/>
+          </a:xfrm>
+          <a:prstGeom prst="rect">
+            <a:avLst/>
+          </a:prstGeom>
+          <a:noFill/>
+        </p:spPr>
+        <p:txBody>
+          <a:bodyPr anchor="t" wrap="square" rtlCol="false" tIns="0" lIns="0" bIns="0" rIns="0">
+            <a:noAutofit/>
+          </a:bodyPr>
+          <a:lstStyle/>
+          <a:p>
+            <a:pPr algn="ctr">
+              <a:lnSpc>
+                <a:spcPts val="1800"/>
+              </a:lnSpc>
+              <a:spcBef>
+                <a:spcPts val="0"/>
+              </a:spcBef>
+              <a:buNone/>
+            </a:pPr>
+            <a:r>
+              <a:rPr lang="en-US" b="true" sz="1800">
+                <a:solidFill>
+                  <a:srgbClr val="FFFFFF"/>
+                </a:solidFill>
+                <a:latin typeface="Arimo Bold"/>
+                <a:ea typeface="Arimo Bold"/>
+                <a:cs typeface="Arimo Bold"/>
+                <a:sym typeface="Arimo Bold"/>
+              </a:rPr>
+              <a:t xml:space="preserve">2</a:t>
+            </a:r>
+          </a:p>
+        </p:txBody>
+      </p:sp>
+      <p:sp>
+        <p:nvSpPr>
+          <p:cNvPr name="Text 124" id="124"/>
+          <p:cNvSpPr txBox="true"/>
+          <p:nvPr/>
+        </p:nvSpPr>
+        <p:spPr>
+          <a:xfrm>
+            <a:off x="11607394" y="4983480"/>
+            <a:ext cx="5647334" cy="292608"/>
+          </a:xfrm>
+          <a:prstGeom prst="rect">
+            <a:avLst/>
+          </a:prstGeom>
+          <a:noFill/>
+        </p:spPr>
+        <p:txBody>
+          <a:bodyPr anchor="t" wrap="square" rtlCol="false" tIns="0" lIns="0" bIns="0" rIns="0">
+            <a:noAutofit/>
+          </a:bodyPr>
+          <a:lstStyle/>
+          <a:p>
+            <a:pPr algn="l">
+              <a:lnSpc>
+                <a:spcPts val="2185"/>
+              </a:lnSpc>
+              <a:spcBef>
+                <a:spcPts val="0"/>
+              </a:spcBef>
+              <a:buNone/>
+            </a:pPr>
+            <a:r>
+              <a:rPr lang="en-US" b="true" sz="1900">
+                <a:solidFill>
+                  <a:srgbClr val="F4F7FF"/>
+                </a:solidFill>
+                <a:latin typeface="Arimo Bold"/>
+                <a:ea typeface="Arimo Bold"/>
+                <a:cs typeface="Arimo Bold"/>
+                <a:sym typeface="Arimo Bold"/>
+              </a:rPr>
+              <a:t xml:space="preserve">Failure debt, ranked</a:t>
+            </a:r>
+          </a:p>
+        </p:txBody>
+      </p:sp>
+      <p:sp>
+        <p:nvSpPr>
+          <p:cNvPr name="Text 125" id="125"/>
+          <p:cNvSpPr txBox="true"/>
+          <p:nvPr/>
+        </p:nvSpPr>
+        <p:spPr>
+          <a:xfrm>
+            <a:off x="11607394" y="5312664"/>
+            <a:ext cx="5647334" cy="539496"/>
+          </a:xfrm>
+          <a:prstGeom prst="rect">
+            <a:avLst/>
+          </a:prstGeom>
+          <a:noFill/>
+        </p:spPr>
+        <p:txBody>
+          <a:bodyPr anchor="t" wrap="square" rtlCol="false" tIns="0" lIns="0" bIns="0" rIns="0">
+            <a:noAutofit/>
+          </a:bodyPr>
+          <a:lstStyle/>
+          <a:p>
+            <a:pPr algn="l">
+              <a:lnSpc>
+                <a:spcPts val="1920"/>
+              </a:lnSpc>
+              <a:spcBef>
+                <a:spcPts val="0"/>
+              </a:spcBef>
+              <a:buNone/>
+            </a:pPr>
+            <a:r>
+              <a:rPr lang="en-US" sz="1500">
+                <a:solidFill>
+                  <a:srgbClr val="D7E3F2"/>
+                </a:solidFill>
+                <a:latin typeface="Arimo"/>
+                <a:ea typeface="Arimo"/>
+                <a:cs typeface="Arimo"/>
+                <a:sym typeface="Arimo"/>
+              </a:rPr>
+              <a:t xml:space="preserve">Recurrence × persistence × impact × spread. The highest unpaid cause leads the page.</a:t>
+            </a:r>
+          </a:p>
+        </p:txBody>
+      </p:sp>
+      <p:sp>
+        <p:nvSpPr>
+          <p:cNvPr name="Card 126" id="126"/>
+          <p:cNvSpPr/>
+          <p:nvPr/>
+        </p:nvSpPr>
+        <p:spPr>
+          <a:xfrm>
+            <a:off x="10711282" y="6144768"/>
+            <a:ext cx="6799478" cy="1252728"/>
+          </a:xfrm>
+          <a:prstGeom prst="roundRect">
+            <a:avLst>
+              <a:gd name="adj" fmla="val 10218"/>
+            </a:avLst>
+          </a:prstGeom>
+          <a:solidFill>
+            <a:srgbClr val="161F31"/>
+          </a:solidFill>
+        </p:spPr>
+        <p:txBody>
+          <a:bodyPr/>
+          <a:lstStyle/>
+          <a:p/>
+        </p:txBody>
+      </p:sp>
+      <p:sp>
+        <p:nvSpPr>
+          <p:cNvPr name="Dot 127" id="127"/>
+          <p:cNvSpPr/>
+          <p:nvPr/>
+        </p:nvSpPr>
+        <p:spPr>
+          <a:xfrm>
+            <a:off x="10985602" y="6419088"/>
+            <a:ext cx="420624" cy="420624"/>
+          </a:xfrm>
+          <a:prstGeom prst="ellipse">
+            <a:avLst/>
+          </a:prstGeom>
+          <a:solidFill>
+            <a:srgbClr val="8B5CF6"/>
+          </a:solidFill>
+        </p:spPr>
+        <p:txBody>
+          <a:bodyPr/>
+          <a:lstStyle/>
+          <a:p/>
+        </p:txBody>
+      </p:sp>
+      <p:sp>
+        <p:nvSpPr>
+          <p:cNvPr name="Text 128" id="128"/>
+          <p:cNvSpPr txBox="true"/>
+          <p:nvPr/>
+        </p:nvSpPr>
+        <p:spPr>
+          <a:xfrm>
+            <a:off x="10985602" y="6503213"/>
+            <a:ext cx="420624" cy="252374"/>
+          </a:xfrm>
+          <a:prstGeom prst="rect">
+            <a:avLst/>
+          </a:prstGeom>
+          <a:noFill/>
+        </p:spPr>
+        <p:txBody>
+          <a:bodyPr anchor="t" wrap="square" rtlCol="false" tIns="0" lIns="0" bIns="0" rIns="0">
+            <a:noAutofit/>
+          </a:bodyPr>
+          <a:lstStyle/>
+          <a:p>
+            <a:pPr algn="ctr">
+              <a:lnSpc>
+                <a:spcPts val="1800"/>
+              </a:lnSpc>
+              <a:spcBef>
+                <a:spcPts val="0"/>
+              </a:spcBef>
+              <a:buNone/>
+            </a:pPr>
+            <a:r>
+              <a:rPr lang="en-US" b="true" sz="1800">
+                <a:solidFill>
+                  <a:srgbClr val="FFFFFF"/>
+                </a:solidFill>
+                <a:latin typeface="Arimo Bold"/>
+                <a:ea typeface="Arimo Bold"/>
+                <a:cs typeface="Arimo Bold"/>
+                <a:sym typeface="Arimo Bold"/>
+              </a:rPr>
+              <a:t xml:space="preserve">3</a:t>
+            </a:r>
+          </a:p>
+        </p:txBody>
+      </p:sp>
+      <p:sp>
+        <p:nvSpPr>
+          <p:cNvPr name="Text 129" id="129"/>
+          <p:cNvSpPr txBox="true"/>
+          <p:nvPr/>
+        </p:nvSpPr>
+        <p:spPr>
+          <a:xfrm>
+            <a:off x="11607394" y="6419088"/>
+            <a:ext cx="5647334" cy="292608"/>
+          </a:xfrm>
+          <a:prstGeom prst="rect">
+            <a:avLst/>
+          </a:prstGeom>
+          <a:noFill/>
+        </p:spPr>
+        <p:txBody>
+          <a:bodyPr anchor="t" wrap="square" rtlCol="false" tIns="0" lIns="0" bIns="0" rIns="0">
+            <a:noAutofit/>
+          </a:bodyPr>
+          <a:lstStyle/>
+          <a:p>
+            <a:pPr algn="l">
+              <a:lnSpc>
+                <a:spcPts val="2185"/>
+              </a:lnSpc>
+              <a:spcBef>
+                <a:spcPts val="0"/>
+              </a:spcBef>
+              <a:buNone/>
+            </a:pPr>
+            <a:r>
+              <a:rPr lang="en-US" b="true" sz="1900">
+                <a:solidFill>
+                  <a:srgbClr val="F4F7FF"/>
+                </a:solidFill>
+                <a:latin typeface="Arimo Bold"/>
+                <a:ea typeface="Arimo Bold"/>
+                <a:cs typeface="Arimo Bold"/>
+                <a:sym typeface="Arimo Bold"/>
+              </a:rPr>
+              <a:t xml:space="preserve">A timeline that proves it</a:t>
+            </a:r>
+          </a:p>
+        </p:txBody>
+      </p:sp>
+      <p:sp>
+        <p:nvSpPr>
+          <p:cNvPr name="Text 130" id="130"/>
+          <p:cNvSpPr txBox="true"/>
+          <p:nvPr/>
+        </p:nvSpPr>
+        <p:spPr>
+          <a:xfrm>
+            <a:off x="11607394" y="6748272"/>
+            <a:ext cx="5647334" cy="539496"/>
+          </a:xfrm>
+          <a:prstGeom prst="rect">
+            <a:avLst/>
+          </a:prstGeom>
+          <a:noFill/>
+        </p:spPr>
+        <p:txBody>
+          <a:bodyPr anchor="t" wrap="square" rtlCol="false" tIns="0" lIns="0" bIns="0" rIns="0">
+            <a:noAutofit/>
+          </a:bodyPr>
+          <a:lstStyle/>
+          <a:p>
+            <a:pPr algn="l">
+              <a:lnSpc>
+                <a:spcPts val="1920"/>
+              </a:lnSpc>
+              <a:spcBef>
+                <a:spcPts val="0"/>
+              </a:spcBef>
+              <a:buNone/>
+            </a:pPr>
+            <a:r>
+              <a:rPr lang="en-US" sz="1500">
+                <a:solidFill>
+                  <a:srgbClr val="D7E3F2"/>
+                </a:solidFill>
+                <a:latin typeface="Arimo"/>
+                <a:ea typeface="Arimo"/>
+                <a:cs typeface="Arimo"/>
+                <a:sym typeface="Arimo"/>
+              </a:rPr>
+              <a:t xml:space="preserve">Each fix is marked where it shipped. Incidents after the marker show it didn't hold.</a:t>
+            </a:r>
+          </a:p>
+        </p:txBody>
+      </p:sp>
+      <p:sp>
+        <p:nvSpPr>
+          <p:cNvPr name="Card 131" id="131"/>
+          <p:cNvSpPr/>
+          <p:nvPr/>
+        </p:nvSpPr>
+        <p:spPr>
+          <a:xfrm>
+            <a:off x="10711282" y="7580376"/>
+            <a:ext cx="6799478" cy="1252728"/>
+          </a:xfrm>
+          <a:prstGeom prst="roundRect">
+            <a:avLst>
+              <a:gd name="adj" fmla="val 10218"/>
+            </a:avLst>
+          </a:prstGeom>
+          <a:solidFill>
+            <a:srgbClr val="161F31"/>
+          </a:solidFill>
+        </p:spPr>
+        <p:txBody>
+          <a:bodyPr/>
+          <a:lstStyle/>
+          <a:p/>
+        </p:txBody>
+      </p:sp>
+      <p:sp>
+        <p:nvSpPr>
+          <p:cNvPr name="Dot 132" id="132"/>
+          <p:cNvSpPr/>
+          <p:nvPr/>
+        </p:nvSpPr>
+        <p:spPr>
+          <a:xfrm>
+            <a:off x="10985602" y="7854696"/>
+            <a:ext cx="420624" cy="420624"/>
+          </a:xfrm>
+          <a:prstGeom prst="ellipse">
+            <a:avLst/>
+          </a:prstGeom>
+          <a:solidFill>
+            <a:srgbClr val="8B5CF6"/>
+          </a:solidFill>
+        </p:spPr>
+        <p:txBody>
+          <a:bodyPr/>
+          <a:lstStyle/>
+          <a:p/>
+        </p:txBody>
+      </p:sp>
+      <p:sp>
+        <p:nvSpPr>
+          <p:cNvPr name="Text 133" id="133"/>
+          <p:cNvSpPr txBox="true"/>
+          <p:nvPr/>
+        </p:nvSpPr>
+        <p:spPr>
+          <a:xfrm>
+            <a:off x="10985602" y="7938821"/>
+            <a:ext cx="420624" cy="252374"/>
+          </a:xfrm>
+          <a:prstGeom prst="rect">
+            <a:avLst/>
+          </a:prstGeom>
+          <a:noFill/>
+        </p:spPr>
+        <p:txBody>
+          <a:bodyPr anchor="t" wrap="square" rtlCol="false" tIns="0" lIns="0" bIns="0" rIns="0">
+            <a:noAutofit/>
+          </a:bodyPr>
+          <a:lstStyle/>
+          <a:p>
+            <a:pPr algn="ctr">
+              <a:lnSpc>
+                <a:spcPts val="1800"/>
+              </a:lnSpc>
+              <a:spcBef>
+                <a:spcPts val="0"/>
+              </a:spcBef>
+              <a:buNone/>
+            </a:pPr>
+            <a:r>
+              <a:rPr lang="en-US" b="true" sz="1800">
+                <a:solidFill>
+                  <a:srgbClr val="FFFFFF"/>
+                </a:solidFill>
+                <a:latin typeface="Arimo Bold"/>
+                <a:ea typeface="Arimo Bold"/>
+                <a:cs typeface="Arimo Bold"/>
+                <a:sym typeface="Arimo Bold"/>
+              </a:rPr>
+              <a:t xml:space="preserve">4</a:t>
+            </a:r>
+          </a:p>
+        </p:txBody>
+      </p:sp>
+      <p:sp>
+        <p:nvSpPr>
+          <p:cNvPr name="Text 134" id="134"/>
+          <p:cNvSpPr txBox="true"/>
+          <p:nvPr/>
+        </p:nvSpPr>
+        <p:spPr>
+          <a:xfrm>
+            <a:off x="11607394" y="7854696"/>
+            <a:ext cx="5647334" cy="292608"/>
+          </a:xfrm>
+          <a:prstGeom prst="rect">
+            <a:avLst/>
+          </a:prstGeom>
+          <a:noFill/>
+        </p:spPr>
+        <p:txBody>
+          <a:bodyPr anchor="t" wrap="square" rtlCol="false" tIns="0" lIns="0" bIns="0" rIns="0">
+            <a:noAutofit/>
+          </a:bodyPr>
+          <a:lstStyle/>
+          <a:p>
+            <a:pPr algn="l">
+              <a:lnSpc>
+                <a:spcPts val="2185"/>
+              </a:lnSpc>
+              <a:spcBef>
+                <a:spcPts val="0"/>
+              </a:spcBef>
+              <a:buNone/>
+            </a:pPr>
+            <a:r>
+              <a:rPr lang="en-US" b="true" sz="1900">
+                <a:solidFill>
+                  <a:srgbClr val="F4F7FF"/>
+                </a:solidFill>
+                <a:latin typeface="Arimo Bold"/>
+                <a:ea typeface="Arimo Bold"/>
+                <a:cs typeface="Arimo Bold"/>
+                <a:sym typeface="Arimo Bold"/>
+              </a:rPr>
+              <a:t xml:space="preserve">Grounded answers</a:t>
+            </a:r>
+          </a:p>
+        </p:txBody>
+      </p:sp>
+      <p:sp>
+        <p:nvSpPr>
+          <p:cNvPr name="Text 135" id="135"/>
+          <p:cNvSpPr txBox="true"/>
+          <p:nvPr/>
+        </p:nvSpPr>
+        <p:spPr>
+          <a:xfrm>
+            <a:off x="11607394" y="8183880"/>
+            <a:ext cx="5647334" cy="539496"/>
+          </a:xfrm>
+          <a:prstGeom prst="rect">
+            <a:avLst/>
+          </a:prstGeom>
+          <a:noFill/>
+        </p:spPr>
+        <p:txBody>
+          <a:bodyPr anchor="t" wrap="square" rtlCol="false" tIns="0" lIns="0" bIns="0" rIns="0">
+            <a:noAutofit/>
+          </a:bodyPr>
+          <a:lstStyle/>
+          <a:p>
+            <a:pPr algn="l">
+              <a:lnSpc>
+                <a:spcPts val="1920"/>
+              </a:lnSpc>
+              <a:spcBef>
+                <a:spcPts val="0"/>
+              </a:spcBef>
+              <a:buNone/>
+            </a:pPr>
+            <a:r>
+              <a:rPr lang="en-US" sz="1500">
+                <a:solidFill>
+                  <a:srgbClr val="D7E3F2"/>
+                </a:solidFill>
+                <a:latin typeface="Arimo"/>
+                <a:ea typeface="Arimo"/>
+                <a:cs typeface="Arimo"/>
+                <a:sym typeface="Arimo"/>
+              </a:rPr>
+              <a:t xml:space="preserve">Suggested questions, answered only from the organisation's own records, with citations.</a:t>
+            </a:r>
+          </a:p>
+        </p:txBody>
+      </p:sp>
+      <p:sp>
+        <p:nvSpPr>
+          <p:cNvPr name="Text 136" id="136"/>
+          <p:cNvSpPr txBox="true"/>
+          <p:nvPr/>
+        </p:nvSpPr>
+        <p:spPr>
+          <a:xfrm>
+            <a:off x="10711282" y="8924544"/>
+            <a:ext cx="6799478" cy="329184"/>
+          </a:xfrm>
+          <a:prstGeom prst="rect">
+            <a:avLst/>
+          </a:prstGeom>
+          <a:noFill/>
+        </p:spPr>
+        <p:txBody>
+          <a:bodyPr anchor="t" wrap="square" rtlCol="false" tIns="0" lIns="0" bIns="0" rIns="0">
+            <a:noAutofit/>
+          </a:bodyPr>
+          <a:lstStyle/>
+          <a:p>
+            <a:pPr algn="l">
+              <a:lnSpc>
+                <a:spcPts val="1439"/>
+              </a:lnSpc>
+              <a:spcBef>
+                <a:spcPts val="0"/>
+              </a:spcBef>
+              <a:buNone/>
+            </a:pPr>
+            <a:r>
+              <a:rPr lang="en-US" sz="1200">
+                <a:solidFill>
+                  <a:srgbClr val="93A4BF"/>
+                </a:solidFill>
+                <a:latin typeface="Arimo"/>
+                <a:ea typeface="Arimo"/>
+                <a:cs typeface="Arimo"/>
+                <a:sym typeface="Arimo"/>
+              </a:rPr>
+              <a:t xml:space="preserve">Captured in fallback mode on the build machine; the RTX 3050 laptop runs Llama 3.2 3B.</a:t>
+            </a:r>
+          </a:p>
+        </p:txBody>
+      </p:sp>
     </p:spTree>
   </p:cSld>
   <p:clrMapOvr>
@@ -18326,6 +18969,1329 @@
                 <a:sym typeface="Arial Bold"/>
               </a:rPr>
               <a:t>08</a:t>
+            </a:r>
+          </a:p>
+        </p:txBody>
+      </p:sp>
+      <p:sp>
+        <p:nvSpPr>
+          <p:cNvPr name="Text 101" id="101"/>
+          <p:cNvSpPr txBox="true"/>
+          <p:nvPr/>
+        </p:nvSpPr>
+        <p:spPr>
+          <a:xfrm>
+            <a:off x="777240" y="1627632"/>
+            <a:ext cx="16733520" cy="713232"/>
+          </a:xfrm>
+          <a:prstGeom prst="rect">
+            <a:avLst/>
+          </a:prstGeom>
+          <a:noFill/>
+        </p:spPr>
+        <p:txBody>
+          <a:bodyPr anchor="t" wrap="square" rtlCol="false" tIns="0" lIns="0" bIns="0" rIns="0">
+            <a:noAutofit/>
+          </a:bodyPr>
+          <a:lstStyle/>
+          <a:p>
+            <a:pPr algn="l">
+              <a:lnSpc>
+                <a:spcPts val="5618"/>
+              </a:lnSpc>
+              <a:spcBef>
+                <a:spcPts val="0"/>
+              </a:spcBef>
+              <a:buNone/>
+            </a:pPr>
+            <a:r>
+              <a:rPr lang="en-US" b="true" sz="5300">
+                <a:solidFill>
+                  <a:srgbClr val="F4F7FF"/>
+                </a:solidFill>
+                <a:latin typeface="Arimo Bold"/>
+                <a:ea typeface="Arimo Bold"/>
+                <a:cs typeface="Arimo Bold"/>
+                <a:sym typeface="Arimo Bold"/>
+              </a:rPr>
+              <a:t xml:space="preserve">Inside the prototype</a:t>
+            </a:r>
+          </a:p>
+        </p:txBody>
+      </p:sp>
+      <p:sp>
+        <p:nvSpPr>
+          <p:cNvPr name="Text 102" id="102"/>
+          <p:cNvSpPr txBox="true"/>
+          <p:nvPr/>
+        </p:nvSpPr>
+        <p:spPr>
+          <a:xfrm>
+            <a:off x="777240" y="2523744"/>
+            <a:ext cx="16733520" cy="512064"/>
+          </a:xfrm>
+          <a:prstGeom prst="rect">
+            <a:avLst/>
+          </a:prstGeom>
+          <a:noFill/>
+        </p:spPr>
+        <p:txBody>
+          <a:bodyPr anchor="t" wrap="square" rtlCol="false" tIns="0" lIns="0" bIns="0" rIns="0">
+            <a:noAutofit/>
+          </a:bodyPr>
+          <a:lstStyle/>
+          <a:p>
+            <a:pPr algn="l">
+              <a:lnSpc>
+                <a:spcPts val="3294"/>
+              </a:lnSpc>
+              <a:spcBef>
+                <a:spcPts val="0"/>
+              </a:spcBef>
+              <a:buNone/>
+            </a:pPr>
+            <a:r>
+              <a:rPr lang="en-US" sz="2700">
+                <a:solidFill>
+                  <a:srgbClr val="C4B5FD"/>
+                </a:solidFill>
+                <a:latin typeface="Arimo"/>
+                <a:ea typeface="Arimo"/>
+                <a:cs typeface="Arimo"/>
+                <a:sym typeface="Arimo"/>
+              </a:rPr>
+              <a:t xml:space="preserve">Four moments from the live demo. Every number is computed on the laptop.</a:t>
+            </a:r>
+          </a:p>
+        </p:txBody>
+      </p:sp>
+      <p:sp>
+        <p:nvSpPr>
+          <p:cNvPr name="Card 103" id="103"/>
+          <p:cNvSpPr/>
+          <p:nvPr/>
+        </p:nvSpPr>
+        <p:spPr>
+          <a:xfrm>
+            <a:off x="777240" y="3273552"/>
+            <a:ext cx="8183880" cy="2852928"/>
+          </a:xfrm>
+          <a:prstGeom prst="roundRect">
+            <a:avLst>
+              <a:gd name="adj" fmla="val 4487"/>
+            </a:avLst>
+          </a:prstGeom>
+          <a:solidFill>
+            <a:srgbClr val="1B2437"/>
+          </a:solidFill>
+        </p:spPr>
+        <p:txBody>
+          <a:bodyPr/>
+          <a:lstStyle/>
+          <a:p/>
+        </p:txBody>
+      </p:sp>
+      <p:sp>
+        <p:nvSpPr>
+          <p:cNvPr name="Dot 104" id="104"/>
+          <p:cNvSpPr/>
+          <p:nvPr/>
+        </p:nvSpPr>
+        <p:spPr>
+          <a:xfrm>
+            <a:off x="1033272" y="3474720"/>
+            <a:ext cx="365760" cy="365760"/>
+          </a:xfrm>
+          <a:prstGeom prst="ellipse">
+            <a:avLst/>
+          </a:prstGeom>
+          <a:solidFill>
+            <a:srgbClr val="8B5CF6"/>
+          </a:solidFill>
+        </p:spPr>
+        <p:txBody>
+          <a:bodyPr/>
+          <a:lstStyle/>
+          <a:p/>
+        </p:txBody>
+      </p:sp>
+      <p:sp>
+        <p:nvSpPr>
+          <p:cNvPr name="Text 105" id="105"/>
+          <p:cNvSpPr txBox="true"/>
+          <p:nvPr/>
+        </p:nvSpPr>
+        <p:spPr>
+          <a:xfrm>
+            <a:off x="1033272" y="3547872"/>
+            <a:ext cx="365760" cy="219456"/>
+          </a:xfrm>
+          <a:prstGeom prst="rect">
+            <a:avLst/>
+          </a:prstGeom>
+          <a:noFill/>
+        </p:spPr>
+        <p:txBody>
+          <a:bodyPr anchor="t" wrap="square" rtlCol="false" tIns="0" lIns="0" bIns="0" rIns="0">
+            <a:noAutofit/>
+          </a:bodyPr>
+          <a:lstStyle/>
+          <a:p>
+            <a:pPr algn="ctr">
+              <a:lnSpc>
+                <a:spcPts val="1500"/>
+              </a:lnSpc>
+              <a:spcBef>
+                <a:spcPts val="0"/>
+              </a:spcBef>
+              <a:buNone/>
+            </a:pPr>
+            <a:r>
+              <a:rPr lang="en-US" b="true" sz="1500">
+                <a:solidFill>
+                  <a:srgbClr val="FFFFFF"/>
+                </a:solidFill>
+                <a:latin typeface="Arimo Bold"/>
+                <a:ea typeface="Arimo Bold"/>
+                <a:cs typeface="Arimo Bold"/>
+                <a:sym typeface="Arimo Bold"/>
+              </a:rPr>
+              <a:t xml:space="preserve">1</a:t>
+            </a:r>
+          </a:p>
+        </p:txBody>
+      </p:sp>
+      <p:sp>
+        <p:nvSpPr>
+          <p:cNvPr name="Text 106" id="106"/>
+          <p:cNvSpPr txBox="true"/>
+          <p:nvPr/>
+        </p:nvSpPr>
+        <p:spPr>
+          <a:xfrm>
+            <a:off x="1563624" y="3502152"/>
+            <a:ext cx="7086600" cy="310896"/>
+          </a:xfrm>
+          <a:prstGeom prst="rect">
+            <a:avLst/>
+          </a:prstGeom>
+          <a:noFill/>
+        </p:spPr>
+        <p:txBody>
+          <a:bodyPr anchor="t" wrap="square" rtlCol="false" tIns="0" lIns="0" bIns="0" rIns="0">
+            <a:noAutofit/>
+          </a:bodyPr>
+          <a:lstStyle/>
+          <a:p>
+            <a:pPr algn="l">
+              <a:lnSpc>
+                <a:spcPts val="2039"/>
+              </a:lnSpc>
+              <a:spcBef>
+                <a:spcPts val="0"/>
+              </a:spcBef>
+              <a:buNone/>
+            </a:pPr>
+            <a:r>
+              <a:rPr lang="en-US" b="true" sz="1700">
+                <a:solidFill>
+                  <a:srgbClr val="F4F7FF"/>
+                </a:solidFill>
+                <a:latin typeface="Arimo Bold"/>
+                <a:ea typeface="Arimo Bold"/>
+                <a:cs typeface="Arimo Bold"/>
+                <a:sym typeface="Arimo Bold"/>
+              </a:rPr>
+              <a:t xml:space="preserve">Every link is inspectable</a:t>
+            </a:r>
+            <a:r>
+              <a:rPr lang="en-US" sz="1400">
+                <a:solidFill>
+                  <a:srgbClr val="93A4BF"/>
+                </a:solidFill>
+                <a:latin typeface="Arimo"/>
+                <a:ea typeface="Arimo"/>
+                <a:cs typeface="Arimo"/>
+                <a:sym typeface="Arimo"/>
+              </a:rPr>
+              <a:t xml:space="preserve">   ·   similarity, confidence, judge</a:t>
+            </a:r>
+          </a:p>
+        </p:txBody>
+      </p:sp>
+      <p:sp>
+        <p:nvSpPr>
+          <p:cNvPr name="Card 107" id="107"/>
+          <p:cNvSpPr/>
+          <p:nvPr/>
+        </p:nvSpPr>
+        <p:spPr>
+          <a:xfrm>
+            <a:off x="9326880" y="3273552"/>
+            <a:ext cx="8183880" cy="2852928"/>
+          </a:xfrm>
+          <a:prstGeom prst="roundRect">
+            <a:avLst>
+              <a:gd name="adj" fmla="val 4487"/>
+            </a:avLst>
+          </a:prstGeom>
+          <a:solidFill>
+            <a:srgbClr val="1B2437"/>
+          </a:solidFill>
+        </p:spPr>
+        <p:txBody>
+          <a:bodyPr/>
+          <a:lstStyle/>
+          <a:p/>
+        </p:txBody>
+      </p:sp>
+      <p:sp>
+        <p:nvSpPr>
+          <p:cNvPr name="Dot 108" id="108"/>
+          <p:cNvSpPr/>
+          <p:nvPr/>
+        </p:nvSpPr>
+        <p:spPr>
+          <a:xfrm>
+            <a:off x="9582912" y="3474720"/>
+            <a:ext cx="365760" cy="365760"/>
+          </a:xfrm>
+          <a:prstGeom prst="ellipse">
+            <a:avLst/>
+          </a:prstGeom>
+          <a:solidFill>
+            <a:srgbClr val="8B5CF6"/>
+          </a:solidFill>
+        </p:spPr>
+        <p:txBody>
+          <a:bodyPr/>
+          <a:lstStyle/>
+          <a:p/>
+        </p:txBody>
+      </p:sp>
+      <p:sp>
+        <p:nvSpPr>
+          <p:cNvPr name="Text 109" id="109"/>
+          <p:cNvSpPr txBox="true"/>
+          <p:nvPr/>
+        </p:nvSpPr>
+        <p:spPr>
+          <a:xfrm>
+            <a:off x="9582912" y="3547872"/>
+            <a:ext cx="365760" cy="219456"/>
+          </a:xfrm>
+          <a:prstGeom prst="rect">
+            <a:avLst/>
+          </a:prstGeom>
+          <a:noFill/>
+        </p:spPr>
+        <p:txBody>
+          <a:bodyPr anchor="t" wrap="square" rtlCol="false" tIns="0" lIns="0" bIns="0" rIns="0">
+            <a:noAutofit/>
+          </a:bodyPr>
+          <a:lstStyle/>
+          <a:p>
+            <a:pPr algn="ctr">
+              <a:lnSpc>
+                <a:spcPts val="1500"/>
+              </a:lnSpc>
+              <a:spcBef>
+                <a:spcPts val="0"/>
+              </a:spcBef>
+              <a:buNone/>
+            </a:pPr>
+            <a:r>
+              <a:rPr lang="en-US" b="true" sz="1500">
+                <a:solidFill>
+                  <a:srgbClr val="FFFFFF"/>
+                </a:solidFill>
+                <a:latin typeface="Arimo Bold"/>
+                <a:ea typeface="Arimo Bold"/>
+                <a:cs typeface="Arimo Bold"/>
+                <a:sym typeface="Arimo Bold"/>
+              </a:rPr>
+              <a:t xml:space="preserve">2</a:t>
+            </a:r>
+          </a:p>
+        </p:txBody>
+      </p:sp>
+      <p:sp>
+        <p:nvSpPr>
+          <p:cNvPr name="Text 110" id="110"/>
+          <p:cNvSpPr txBox="true"/>
+          <p:nvPr/>
+        </p:nvSpPr>
+        <p:spPr>
+          <a:xfrm>
+            <a:off x="10113264" y="3502152"/>
+            <a:ext cx="7086600" cy="310896"/>
+          </a:xfrm>
+          <a:prstGeom prst="rect">
+            <a:avLst/>
+          </a:prstGeom>
+          <a:noFill/>
+        </p:spPr>
+        <p:txBody>
+          <a:bodyPr anchor="t" wrap="square" rtlCol="false" tIns="0" lIns="0" bIns="0" rIns="0">
+            <a:noAutofit/>
+          </a:bodyPr>
+          <a:lstStyle/>
+          <a:p>
+            <a:pPr algn="l">
+              <a:lnSpc>
+                <a:spcPts val="2039"/>
+              </a:lnSpc>
+              <a:spcBef>
+                <a:spcPts val="0"/>
+              </a:spcBef>
+              <a:buNone/>
+            </a:pPr>
+            <a:r>
+              <a:rPr lang="en-US" b="true" sz="1700">
+                <a:solidFill>
+                  <a:srgbClr val="F4F7FF"/>
+                </a:solidFill>
+                <a:latin typeface="Arimo Bold"/>
+                <a:ea typeface="Arimo Bold"/>
+                <a:cs typeface="Arimo Bold"/>
+                <a:sym typeface="Arimo Bold"/>
+              </a:rPr>
+              <a:t xml:space="preserve">Warned before the change ships</a:t>
+            </a:r>
+            <a:r>
+              <a:rPr lang="en-US" sz="1400">
+                <a:solidFill>
+                  <a:srgbClr val="93A4BF"/>
+                </a:solidFill>
+                <a:latin typeface="Arimo"/>
+                <a:ea typeface="Arimo"/>
+                <a:cs typeface="Arimo"/>
+                <a:sym typeface="Arimo"/>
+              </a:rPr>
+              <a:t xml:space="preserve">   ·   CHG-88 checked against CLU-001</a:t>
+            </a:r>
+          </a:p>
+        </p:txBody>
+      </p:sp>
+      <p:sp>
+        <p:nvSpPr>
+          <p:cNvPr name="Card 111" id="111"/>
+          <p:cNvSpPr/>
+          <p:nvPr/>
+        </p:nvSpPr>
+        <p:spPr>
+          <a:xfrm>
+            <a:off x="777240" y="6400800"/>
+            <a:ext cx="8183880" cy="2852928"/>
+          </a:xfrm>
+          <a:prstGeom prst="roundRect">
+            <a:avLst>
+              <a:gd name="adj" fmla="val 4487"/>
+            </a:avLst>
+          </a:prstGeom>
+          <a:solidFill>
+            <a:srgbClr val="1B2437"/>
+          </a:solidFill>
+        </p:spPr>
+        <p:txBody>
+          <a:bodyPr/>
+          <a:lstStyle/>
+          <a:p/>
+        </p:txBody>
+      </p:sp>
+      <p:sp>
+        <p:nvSpPr>
+          <p:cNvPr name="Dot 112" id="112"/>
+          <p:cNvSpPr/>
+          <p:nvPr/>
+        </p:nvSpPr>
+        <p:spPr>
+          <a:xfrm>
+            <a:off x="1033272" y="6601968"/>
+            <a:ext cx="365760" cy="365760"/>
+          </a:xfrm>
+          <a:prstGeom prst="ellipse">
+            <a:avLst/>
+          </a:prstGeom>
+          <a:solidFill>
+            <a:srgbClr val="8B5CF6"/>
+          </a:solidFill>
+        </p:spPr>
+        <p:txBody>
+          <a:bodyPr/>
+          <a:lstStyle/>
+          <a:p/>
+        </p:txBody>
+      </p:sp>
+      <p:sp>
+        <p:nvSpPr>
+          <p:cNvPr name="Text 113" id="113"/>
+          <p:cNvSpPr txBox="true"/>
+          <p:nvPr/>
+        </p:nvSpPr>
+        <p:spPr>
+          <a:xfrm>
+            <a:off x="1033272" y="6675120"/>
+            <a:ext cx="365760" cy="219456"/>
+          </a:xfrm>
+          <a:prstGeom prst="rect">
+            <a:avLst/>
+          </a:prstGeom>
+          <a:noFill/>
+        </p:spPr>
+        <p:txBody>
+          <a:bodyPr anchor="t" wrap="square" rtlCol="false" tIns="0" lIns="0" bIns="0" rIns="0">
+            <a:noAutofit/>
+          </a:bodyPr>
+          <a:lstStyle/>
+          <a:p>
+            <a:pPr algn="ctr">
+              <a:lnSpc>
+                <a:spcPts val="1500"/>
+              </a:lnSpc>
+              <a:spcBef>
+                <a:spcPts val="0"/>
+              </a:spcBef>
+              <a:buNone/>
+            </a:pPr>
+            <a:r>
+              <a:rPr lang="en-US" b="true" sz="1500">
+                <a:solidFill>
+                  <a:srgbClr val="FFFFFF"/>
+                </a:solidFill>
+                <a:latin typeface="Arimo Bold"/>
+                <a:ea typeface="Arimo Bold"/>
+                <a:cs typeface="Arimo Bold"/>
+                <a:sym typeface="Arimo Bold"/>
+              </a:rPr>
+              <a:t xml:space="preserve">3</a:t>
+            </a:r>
+          </a:p>
+        </p:txBody>
+      </p:sp>
+      <p:sp>
+        <p:nvSpPr>
+          <p:cNvPr name="Text 114" id="114"/>
+          <p:cNvSpPr txBox="true"/>
+          <p:nvPr/>
+        </p:nvSpPr>
+        <p:spPr>
+          <a:xfrm>
+            <a:off x="1563624" y="6629400"/>
+            <a:ext cx="7086600" cy="310896"/>
+          </a:xfrm>
+          <a:prstGeom prst="rect">
+            <a:avLst/>
+          </a:prstGeom>
+          <a:noFill/>
+        </p:spPr>
+        <p:txBody>
+          <a:bodyPr anchor="t" wrap="square" rtlCol="false" tIns="0" lIns="0" bIns="0" rIns="0">
+            <a:noAutofit/>
+          </a:bodyPr>
+          <a:lstStyle/>
+          <a:p>
+            <a:pPr algn="l">
+              <a:lnSpc>
+                <a:spcPts val="2039"/>
+              </a:lnSpc>
+              <a:spcBef>
+                <a:spcPts val="0"/>
+              </a:spcBef>
+              <a:buNone/>
+            </a:pPr>
+            <a:r>
+              <a:rPr lang="en-US" b="true" sz="1700">
+                <a:solidFill>
+                  <a:srgbClr val="F4F7FF"/>
+                </a:solidFill>
+                <a:latin typeface="Arimo Bold"/>
+                <a:ea typeface="Arimo Bold"/>
+                <a:cs typeface="Arimo Bold"/>
+                <a:sym typeface="Arimo Bold"/>
+              </a:rPr>
+              <a:t xml:space="preserve">Evidence, not authority</a:t>
+            </a:r>
+            <a:r>
+              <a:rPr lang="en-US" sz="1400">
+                <a:solidFill>
+                  <a:srgbClr val="93A4BF"/>
+                </a:solidFill>
+                <a:latin typeface="Arimo"/>
+                <a:ea typeface="Arimo"/>
+                <a:cs typeface="Arimo"/>
+                <a:sym typeface="Arimo"/>
+              </a:rPr>
+              <a:t xml:space="preserve">   ·   injection quarantined, send blocked</a:t>
+            </a:r>
+          </a:p>
+        </p:txBody>
+      </p:sp>
+      <p:sp>
+        <p:nvSpPr>
+          <p:cNvPr name="Card 115" id="115"/>
+          <p:cNvSpPr/>
+          <p:nvPr/>
+        </p:nvSpPr>
+        <p:spPr>
+          <a:xfrm>
+            <a:off x="9326880" y="6400800"/>
+            <a:ext cx="8183880" cy="2852928"/>
+          </a:xfrm>
+          <a:prstGeom prst="roundRect">
+            <a:avLst>
+              <a:gd name="adj" fmla="val 4487"/>
+            </a:avLst>
+          </a:prstGeom>
+          <a:solidFill>
+            <a:srgbClr val="1B2437"/>
+          </a:solidFill>
+        </p:spPr>
+        <p:txBody>
+          <a:bodyPr/>
+          <a:lstStyle/>
+          <a:p/>
+        </p:txBody>
+      </p:sp>
+      <p:sp>
+        <p:nvSpPr>
+          <p:cNvPr name="Dot 116" id="116"/>
+          <p:cNvSpPr/>
+          <p:nvPr/>
+        </p:nvSpPr>
+        <p:spPr>
+          <a:xfrm>
+            <a:off x="9582912" y="6601968"/>
+            <a:ext cx="365760" cy="365760"/>
+          </a:xfrm>
+          <a:prstGeom prst="ellipse">
+            <a:avLst/>
+          </a:prstGeom>
+          <a:solidFill>
+            <a:srgbClr val="8B5CF6"/>
+          </a:solidFill>
+        </p:spPr>
+        <p:txBody>
+          <a:bodyPr/>
+          <a:lstStyle/>
+          <a:p/>
+        </p:txBody>
+      </p:sp>
+      <p:sp>
+        <p:nvSpPr>
+          <p:cNvPr name="Text 117" id="117"/>
+          <p:cNvSpPr txBox="true"/>
+          <p:nvPr/>
+        </p:nvSpPr>
+        <p:spPr>
+          <a:xfrm>
+            <a:off x="9582912" y="6675120"/>
+            <a:ext cx="365760" cy="219456"/>
+          </a:xfrm>
+          <a:prstGeom prst="rect">
+            <a:avLst/>
+          </a:prstGeom>
+          <a:noFill/>
+        </p:spPr>
+        <p:txBody>
+          <a:bodyPr anchor="t" wrap="square" rtlCol="false" tIns="0" lIns="0" bIns="0" rIns="0">
+            <a:noAutofit/>
+          </a:bodyPr>
+          <a:lstStyle/>
+          <a:p>
+            <a:pPr algn="ctr">
+              <a:lnSpc>
+                <a:spcPts val="1500"/>
+              </a:lnSpc>
+              <a:spcBef>
+                <a:spcPts val="0"/>
+              </a:spcBef>
+              <a:buNone/>
+            </a:pPr>
+            <a:r>
+              <a:rPr lang="en-US" b="true" sz="1500">
+                <a:solidFill>
+                  <a:srgbClr val="FFFFFF"/>
+                </a:solidFill>
+                <a:latin typeface="Arimo Bold"/>
+                <a:ea typeface="Arimo Bold"/>
+                <a:cs typeface="Arimo Bold"/>
+                <a:sym typeface="Arimo Bold"/>
+              </a:rPr>
+              <a:t xml:space="preserve">4</a:t>
+            </a:r>
+          </a:p>
+        </p:txBody>
+      </p:sp>
+      <p:sp>
+        <p:nvSpPr>
+          <p:cNvPr name="Text 118" id="118"/>
+          <p:cNvSpPr txBox="true"/>
+          <p:nvPr/>
+        </p:nvSpPr>
+        <p:spPr>
+          <a:xfrm>
+            <a:off x="10113264" y="6629400"/>
+            <a:ext cx="7086600" cy="310896"/>
+          </a:xfrm>
+          <a:prstGeom prst="rect">
+            <a:avLst/>
+          </a:prstGeom>
+          <a:noFill/>
+        </p:spPr>
+        <p:txBody>
+          <a:bodyPr anchor="t" wrap="square" rtlCol="false" tIns="0" lIns="0" bIns="0" rIns="0">
+            <a:noAutofit/>
+          </a:bodyPr>
+          <a:lstStyle/>
+          <a:p>
+            <a:pPr algn="l">
+              <a:lnSpc>
+                <a:spcPts val="2039"/>
+              </a:lnSpc>
+              <a:spcBef>
+                <a:spcPts val="0"/>
+              </a:spcBef>
+              <a:buNone/>
+            </a:pPr>
+            <a:r>
+              <a:rPr lang="en-US" b="true" sz="1700">
+                <a:solidFill>
+                  <a:srgbClr val="F4F7FF"/>
+                </a:solidFill>
+                <a:latin typeface="Arimo Bold"/>
+                <a:ea typeface="Arimo Bold"/>
+                <a:cs typeface="Arimo Bold"/>
+                <a:sym typeface="Arimo Bold"/>
+              </a:rPr>
+              <a:t xml:space="preserve">Tamper-evident ledger</a:t>
+            </a:r>
+            <a:r>
+              <a:rPr lang="en-US" sz="1400">
+                <a:solidFill>
+                  <a:srgbClr val="93A4BF"/>
+                </a:solidFill>
+                <a:latin typeface="Arimo"/>
+                <a:ea typeface="Arimo"/>
+                <a:cs typeface="Arimo"/>
+                <a:sym typeface="Arimo"/>
+              </a:rPr>
+              <a:t xml:space="preserve">   ·   one edit breaks the chain</a:t>
+            </a:r>
+          </a:p>
+        </p:txBody>
+      </p:sp>
+      <p:pic>
+        <p:nvPicPr>
+          <p:cNvPr id="119" name="Picture 118" descr="deck-why.jpg"/>
+          <p:cNvPicPr>
+            <a:picLocks noChangeAspect="1"/>
+          </p:cNvPicPr>
+          <p:nvPr/>
+        </p:nvPicPr>
+        <p:blipFill>
+          <a:blip r:embed="rId6"/>
+          <a:stretch>
+            <a:fillRect/>
+          </a:stretch>
+        </p:blipFill>
+        <p:spPr>
+          <a:xfrm>
+            <a:off x="1972313" y="3913632"/>
+            <a:ext cx="5793734" cy="2084832"/>
+          </a:xfrm>
+          <a:prstGeom prst="rect">
+            <a:avLst/>
+          </a:prstGeom>
+        </p:spPr>
+      </p:pic>
+      <p:pic>
+        <p:nvPicPr>
+          <p:cNvPr id="120" name="Picture 119" descr="deck-preflight.jpg"/>
+          <p:cNvPicPr>
+            <a:picLocks noChangeAspect="1"/>
+          </p:cNvPicPr>
+          <p:nvPr/>
+        </p:nvPicPr>
+        <p:blipFill>
+          <a:blip r:embed="rId7"/>
+          <a:stretch>
+            <a:fillRect/>
+          </a:stretch>
+        </p:blipFill>
+        <p:spPr>
+          <a:xfrm>
+            <a:off x="10569550" y="3913632"/>
+            <a:ext cx="5698541" cy="2084832"/>
+          </a:xfrm>
+          <a:prstGeom prst="rect">
+            <a:avLst/>
+          </a:prstGeom>
+        </p:spPr>
+      </p:pic>
+      <p:pic>
+        <p:nvPicPr>
+          <p:cNvPr id="121" name="Picture 120" descr="deck-policy.jpg"/>
+          <p:cNvPicPr>
+            <a:picLocks noChangeAspect="1"/>
+          </p:cNvPicPr>
+          <p:nvPr/>
+        </p:nvPicPr>
+        <p:blipFill>
+          <a:blip r:embed="rId8"/>
+          <a:stretch>
+            <a:fillRect/>
+          </a:stretch>
+        </p:blipFill>
+        <p:spPr>
+          <a:xfrm>
+            <a:off x="961609" y="7040880"/>
+            <a:ext cx="7815142" cy="2084832"/>
+          </a:xfrm>
+          <a:prstGeom prst="rect">
+            <a:avLst/>
+          </a:prstGeom>
+        </p:spPr>
+      </p:pic>
+      <p:pic>
+        <p:nvPicPr>
+          <p:cNvPr id="122" name="Picture 121" descr="deck-audit.jpg"/>
+          <p:cNvPicPr>
+            <a:picLocks noChangeAspect="1"/>
+          </p:cNvPicPr>
+          <p:nvPr/>
+        </p:nvPicPr>
+        <p:blipFill>
+          <a:blip r:embed="rId9"/>
+          <a:stretch>
+            <a:fillRect/>
+          </a:stretch>
+        </p:blipFill>
+        <p:spPr>
+          <a:xfrm>
+            <a:off x="10338528" y="7040880"/>
+            <a:ext cx="6160585" cy="2084832"/>
+          </a:xfrm>
+          <a:prstGeom prst="rect">
+            <a:avLst/>
+          </a:prstGeom>
+        </p:spPr>
+      </p:pic>
+    </p:spTree>
+  </p:cSld>
+  <p:clrMapOvr>
+    <a:masterClrMapping/>
+  </p:clrMapOvr>
+</p:sld>
+</file>
+
+<file path=ppt/slides/slide9.xml><?xml version="1.0" encoding="utf-8"?>
+<p:sld xmlns:p="http://schemas.openxmlformats.org/presentationml/2006/main" xmlns:a="http://schemas.openxmlformats.org/drawingml/2006/main" xmlns:r="http://schemas.openxmlformats.org/officeDocument/2006/relationships">
+  <p:cSld>
+    <p:spTree>
+      <p:nvGrpSpPr>
+        <p:cNvPr id="1" name=""/>
+        <p:cNvGrpSpPr/>
+        <p:nvPr/>
+      </p:nvGrpSpPr>
+      <p:grpSpPr>
+        <a:xfrm>
+          <a:off x="0" y="0"/>
+          <a:ext cx="0" cy="0"/>
+          <a:chOff x="0" y="0"/>
+          <a:chExt cx="0" cy="0"/>
+        </a:xfrm>
+      </p:grpSpPr>
+      <p:grpSp>
+        <p:nvGrpSpPr>
+          <p:cNvPr name="Group 2" id="2"/>
+          <p:cNvGrpSpPr/>
+          <p:nvPr/>
+        </p:nvGrpSpPr>
+        <p:grpSpPr>
+          <a:xfrm rot="0">
+            <a:off x="0" y="0"/>
+            <a:ext cx="18288000" cy="9688982"/>
+            <a:chOff x="0" y="0"/>
+            <a:chExt cx="24384000" cy="12918643"/>
+          </a:xfrm>
+        </p:grpSpPr>
+        <p:sp>
+          <p:nvSpPr>
+            <p:cNvPr name="Freeform 3" id="3"/>
+            <p:cNvSpPr/>
+            <p:nvPr/>
+          </p:nvSpPr>
+          <p:spPr>
+            <a:xfrm flipH="false" flipV="false" rot="0">
+              <a:off x="0" y="0"/>
+              <a:ext cx="24384000" cy="12918643"/>
+            </a:xfrm>
+            <a:custGeom>
+              <a:avLst/>
+              <a:gdLst/>
+              <a:ahLst/>
+              <a:cxnLst/>
+              <a:rect r="r" b="b" t="t" l="l"/>
+              <a:pathLst>
+                <a:path h="12918643" w="24384000">
+                  <a:moveTo>
+                    <a:pt x="0" y="0"/>
+                  </a:moveTo>
+                  <a:lnTo>
+                    <a:pt x="24384000" y="0"/>
+                  </a:lnTo>
+                  <a:lnTo>
+                    <a:pt x="24384000" y="12918643"/>
+                  </a:lnTo>
+                  <a:lnTo>
+                    <a:pt x="0" y="12918643"/>
+                  </a:lnTo>
+                  <a:close/>
+                </a:path>
+              </a:pathLst>
+            </a:custGeom>
+            <a:solidFill>
+              <a:srgbClr val="050816"/>
+            </a:solidFill>
+          </p:spPr>
+        </p:sp>
+      </p:grpSp>
+      <p:grpSp>
+        <p:nvGrpSpPr>
+          <p:cNvPr name="Group 4" id="4"/>
+          <p:cNvGrpSpPr/>
+          <p:nvPr/>
+        </p:nvGrpSpPr>
+        <p:grpSpPr>
+          <a:xfrm rot="0">
+            <a:off x="-47625" y="0"/>
+            <a:ext cx="18288000" cy="10287000"/>
+            <a:chOff x="0" y="0"/>
+            <a:chExt cx="24384000" cy="13716000"/>
+          </a:xfrm>
+        </p:grpSpPr>
+        <p:sp>
+          <p:nvSpPr>
+            <p:cNvPr name="Freeform 5" id="5"/>
+            <p:cNvSpPr/>
+            <p:nvPr/>
+          </p:nvSpPr>
+          <p:spPr>
+            <a:xfrm flipH="false" flipV="false" rot="0">
+              <a:off x="0" y="0"/>
+              <a:ext cx="24384000" cy="13716000"/>
+            </a:xfrm>
+            <a:custGeom>
+              <a:avLst/>
+              <a:gdLst/>
+              <a:ahLst/>
+              <a:cxnLst/>
+              <a:rect r="r" b="b" t="t" l="l"/>
+              <a:pathLst>
+                <a:path h="13716000" w="24384000">
+                  <a:moveTo>
+                    <a:pt x="0" y="0"/>
+                  </a:moveTo>
+                  <a:lnTo>
+                    <a:pt x="24384000" y="0"/>
+                  </a:lnTo>
+                  <a:lnTo>
+                    <a:pt x="24384000" y="13716000"/>
+                  </a:lnTo>
+                  <a:lnTo>
+                    <a:pt x="0" y="13716000"/>
+                  </a:lnTo>
+                  <a:close/>
+                </a:path>
+              </a:pathLst>
+            </a:custGeom>
+            <a:solidFill>
+              <a:srgbClr val="111827"/>
+            </a:solidFill>
+          </p:spPr>
+        </p:sp>
+      </p:grpSp>
+      <p:grpSp>
+        <p:nvGrpSpPr>
+          <p:cNvPr name="Group 6" id="6"/>
+          <p:cNvGrpSpPr/>
+          <p:nvPr/>
+        </p:nvGrpSpPr>
+        <p:grpSpPr>
+          <a:xfrm rot="0">
+            <a:off x="0" y="9528867"/>
+            <a:ext cx="18288000" cy="758133"/>
+            <a:chOff x="0" y="0"/>
+            <a:chExt cx="24384000" cy="1010844"/>
+          </a:xfrm>
+        </p:grpSpPr>
+        <p:sp>
+          <p:nvSpPr>
+            <p:cNvPr name="Freeform 7" id="7"/>
+            <p:cNvSpPr/>
+            <p:nvPr/>
+          </p:nvSpPr>
+          <p:spPr>
+            <a:xfrm flipH="false" flipV="false" rot="0">
+              <a:off x="0" y="0"/>
+              <a:ext cx="24384000" cy="1010793"/>
+            </a:xfrm>
+            <a:custGeom>
+              <a:avLst/>
+              <a:gdLst/>
+              <a:ahLst/>
+              <a:cxnLst/>
+              <a:rect r="r" b="b" t="t" l="l"/>
+              <a:pathLst>
+                <a:path h="1010793" w="24384000">
+                  <a:moveTo>
+                    <a:pt x="0" y="0"/>
+                  </a:moveTo>
+                  <a:lnTo>
+                    <a:pt x="24384000" y="0"/>
+                  </a:lnTo>
+                  <a:lnTo>
+                    <a:pt x="24384000" y="1010793"/>
+                  </a:lnTo>
+                  <a:lnTo>
+                    <a:pt x="0" y="1010793"/>
+                  </a:lnTo>
+                  <a:close/>
+                </a:path>
+              </a:pathLst>
+            </a:custGeom>
+            <a:solidFill>
+              <a:srgbClr val="8B5CF6"/>
+            </a:solidFill>
+          </p:spPr>
+        </p:sp>
+      </p:grpSp>
+      <p:grpSp>
+        <p:nvGrpSpPr>
+          <p:cNvPr name="Group 8" id="8"/>
+          <p:cNvGrpSpPr/>
+          <p:nvPr/>
+        </p:nvGrpSpPr>
+        <p:grpSpPr>
+          <a:xfrm rot="0">
+            <a:off x="243783" y="180823"/>
+            <a:ext cx="1203122" cy="992686"/>
+            <a:chOff x="0" y="0"/>
+            <a:chExt cx="1604162" cy="1323581"/>
+          </a:xfrm>
+        </p:grpSpPr>
+        <p:sp>
+          <p:nvSpPr>
+            <p:cNvPr name="Freeform 9" id="9" descr="preencoded.png"/>
+            <p:cNvSpPr/>
+            <p:nvPr/>
+          </p:nvSpPr>
+          <p:spPr>
+            <a:xfrm flipH="false" flipV="false" rot="0">
+              <a:off x="0" y="0"/>
+              <a:ext cx="1604137" cy="1323594"/>
+            </a:xfrm>
+            <a:custGeom>
+              <a:avLst/>
+              <a:gdLst/>
+              <a:ahLst/>
+              <a:cxnLst/>
+              <a:rect r="r" b="b" t="t" l="l"/>
+              <a:pathLst>
+                <a:path h="1323594" w="1604137">
+                  <a:moveTo>
+                    <a:pt x="0" y="0"/>
+                  </a:moveTo>
+                  <a:lnTo>
+                    <a:pt x="1604137" y="0"/>
+                  </a:lnTo>
+                  <a:lnTo>
+                    <a:pt x="1604137" y="1323594"/>
+                  </a:lnTo>
+                  <a:lnTo>
+                    <a:pt x="0" y="1323594"/>
+                  </a:lnTo>
+                  <a:lnTo>
+                    <a:pt x="0" y="0"/>
+                  </a:lnTo>
+                  <a:close/>
+                </a:path>
+              </a:pathLst>
+            </a:custGeom>
+            <a:blipFill>
+              <a:blip r:embed="rId2"/>
+              <a:stretch>
+                <a:fillRect l="0" t="0" r="-190" b="0"/>
+              </a:stretch>
+            </a:blipFill>
+          </p:spPr>
+        </p:sp>
+      </p:grpSp>
+      <p:grpSp>
+        <p:nvGrpSpPr>
+          <p:cNvPr name="Group 10" id="10"/>
+          <p:cNvGrpSpPr/>
+          <p:nvPr/>
+        </p:nvGrpSpPr>
+        <p:grpSpPr>
+          <a:xfrm rot="0">
+            <a:off x="17262719" y="150914"/>
+            <a:ext cx="754409" cy="1052665"/>
+            <a:chOff x="0" y="0"/>
+            <a:chExt cx="1005878" cy="1403553"/>
+          </a:xfrm>
+        </p:grpSpPr>
+        <p:sp>
+          <p:nvSpPr>
+            <p:cNvPr name="Freeform 11" id="11" descr="preencoded.png"/>
+            <p:cNvSpPr/>
+            <p:nvPr/>
+          </p:nvSpPr>
+          <p:spPr>
+            <a:xfrm flipH="false" flipV="false" rot="0">
+              <a:off x="0" y="0"/>
+              <a:ext cx="1005840" cy="1403604"/>
+            </a:xfrm>
+            <a:custGeom>
+              <a:avLst/>
+              <a:gdLst/>
+              <a:ahLst/>
+              <a:cxnLst/>
+              <a:rect r="r" b="b" t="t" l="l"/>
+              <a:pathLst>
+                <a:path h="1403604" w="1005840">
+                  <a:moveTo>
+                    <a:pt x="0" y="0"/>
+                  </a:moveTo>
+                  <a:lnTo>
+                    <a:pt x="1005840" y="0"/>
+                  </a:lnTo>
+                  <a:lnTo>
+                    <a:pt x="1005840" y="1403604"/>
+                  </a:lnTo>
+                  <a:lnTo>
+                    <a:pt x="0" y="1403604"/>
+                  </a:lnTo>
+                  <a:lnTo>
+                    <a:pt x="0" y="0"/>
+                  </a:lnTo>
+                  <a:close/>
+                </a:path>
+              </a:pathLst>
+            </a:custGeom>
+            <a:blipFill>
+              <a:blip r:embed="rId3"/>
+              <a:stretch>
+                <a:fillRect l="0" t="0" r="-3" b="-59"/>
+              </a:stretch>
+            </a:blipFill>
+          </p:spPr>
+        </p:sp>
+      </p:grpSp>
+      <p:grpSp>
+        <p:nvGrpSpPr>
+          <p:cNvPr name="Group 12" id="12"/>
+          <p:cNvGrpSpPr/>
+          <p:nvPr/>
+        </p:nvGrpSpPr>
+        <p:grpSpPr>
+          <a:xfrm rot="0">
+            <a:off x="15847666" y="150914"/>
+            <a:ext cx="1007859" cy="1007859"/>
+            <a:chOff x="0" y="0"/>
+            <a:chExt cx="1343812" cy="1343812"/>
+          </a:xfrm>
+        </p:grpSpPr>
+        <p:sp>
+          <p:nvSpPr>
+            <p:cNvPr name="Freeform 13" id="13" descr="preencoded.png"/>
+            <p:cNvSpPr/>
+            <p:nvPr/>
+          </p:nvSpPr>
+          <p:spPr>
+            <a:xfrm flipH="false" flipV="false" rot="0">
+              <a:off x="0" y="0"/>
+              <a:ext cx="1343787" cy="1343787"/>
+            </a:xfrm>
+            <a:custGeom>
+              <a:avLst/>
+              <a:gdLst/>
+              <a:ahLst/>
+              <a:cxnLst/>
+              <a:rect r="r" b="b" t="t" l="l"/>
+              <a:pathLst>
+                <a:path h="1343787" w="1343787">
+                  <a:moveTo>
+                    <a:pt x="0" y="0"/>
+                  </a:moveTo>
+                  <a:lnTo>
+                    <a:pt x="1343787" y="0"/>
+                  </a:lnTo>
+                  <a:lnTo>
+                    <a:pt x="1343787" y="1343787"/>
+                  </a:lnTo>
+                  <a:lnTo>
+                    <a:pt x="0" y="1343787"/>
+                  </a:lnTo>
+                  <a:lnTo>
+                    <a:pt x="0" y="0"/>
+                  </a:lnTo>
+                  <a:close/>
+                </a:path>
+              </a:pathLst>
+            </a:custGeom>
+            <a:blipFill>
+              <a:blip r:embed="rId4"/>
+              <a:stretch>
+                <a:fillRect l="0" t="0" r="-1" b="-1"/>
+              </a:stretch>
+            </a:blipFill>
+          </p:spPr>
+        </p:sp>
+      </p:grpSp>
+      <p:grpSp>
+        <p:nvGrpSpPr>
+          <p:cNvPr name="Group 14" id="14"/>
+          <p:cNvGrpSpPr/>
+          <p:nvPr/>
+        </p:nvGrpSpPr>
+        <p:grpSpPr>
+          <a:xfrm rot="0">
+            <a:off x="1447057" y="150914"/>
+            <a:ext cx="1007859" cy="1007859"/>
+            <a:chOff x="0" y="0"/>
+            <a:chExt cx="1343812" cy="1343812"/>
+          </a:xfrm>
+        </p:grpSpPr>
+        <p:sp>
+          <p:nvSpPr>
+            <p:cNvPr name="Freeform 15" id="15" descr="preencoded.png"/>
+            <p:cNvSpPr/>
+            <p:nvPr/>
+          </p:nvSpPr>
+          <p:spPr>
+            <a:xfrm flipH="false" flipV="false" rot="0">
+              <a:off x="0" y="0"/>
+              <a:ext cx="1343787" cy="1343787"/>
+            </a:xfrm>
+            <a:custGeom>
+              <a:avLst/>
+              <a:gdLst/>
+              <a:ahLst/>
+              <a:cxnLst/>
+              <a:rect r="r" b="b" t="t" l="l"/>
+              <a:pathLst>
+                <a:path h="1343787" w="1343787">
+                  <a:moveTo>
+                    <a:pt x="0" y="0"/>
+                  </a:moveTo>
+                  <a:lnTo>
+                    <a:pt x="1343787" y="0"/>
+                  </a:lnTo>
+                  <a:lnTo>
+                    <a:pt x="1343787" y="1343787"/>
+                  </a:lnTo>
+                  <a:lnTo>
+                    <a:pt x="0" y="1343787"/>
+                  </a:lnTo>
+                  <a:lnTo>
+                    <a:pt x="0" y="0"/>
+                  </a:lnTo>
+                  <a:close/>
+                </a:path>
+              </a:pathLst>
+            </a:custGeom>
+            <a:blipFill>
+              <a:blip r:embed="rId5"/>
+              <a:stretch>
+                <a:fillRect l="0" t="0" r="-1" b="-1"/>
+              </a:stretch>
+            </a:blipFill>
+          </p:spPr>
+        </p:sp>
+      </p:grpSp>
+      <p:sp>
+        <p:nvSpPr>
+          <p:cNvPr name="TextBox 16" id="16"/>
+          <p:cNvSpPr txBox="true"/>
+          <p:nvPr/>
+        </p:nvSpPr>
+        <p:spPr>
+          <a:xfrm rot="0">
+            <a:off x="3833527" y="343929"/>
+            <a:ext cx="11042552" cy="923325"/>
+          </a:xfrm>
+          <a:prstGeom prst="rect">
+            <a:avLst/>
+          </a:prstGeom>
+        </p:spPr>
+        <p:txBody>
+          <a:bodyPr anchor="t" rtlCol="false" tIns="0" lIns="0" bIns="0" rIns="0">
+            <a:spAutoFit/>
+          </a:bodyPr>
+          <a:lstStyle/>
+          <a:p>
+            <a:pPr algn="ctr">
+              <a:lnSpc>
+                <a:spcPts val="5519"/>
+              </a:lnSpc>
+            </a:pPr>
+            <a:r>
+              <a:rPr lang="en-US" b="true" sz="4599">
+                <a:solidFill>
+                  <a:srgbClr val="FFFFFF"/>
+                </a:solidFill>
+                <a:latin typeface="Arial Bold"/>
+                <a:ea typeface="Arial Bold"/>
+                <a:cs typeface="Arial Bold"/>
+                <a:sym typeface="Arial Bold"/>
+              </a:rPr>
+              <a:t>ASYNC 2026</a:t>
+            </a:r>
+          </a:p>
+        </p:txBody>
+      </p:sp>
+      <p:sp>
+        <p:nvSpPr>
+          <p:cNvPr name="TextBox 20" id="20"/>
+          <p:cNvSpPr txBox="true"/>
+          <p:nvPr/>
+        </p:nvSpPr>
+        <p:spPr>
+          <a:xfrm rot="0">
+            <a:off x="17406799" y="9677171"/>
+            <a:ext cx="466249" cy="523875"/>
+          </a:xfrm>
+          <a:prstGeom prst="rect">
+            <a:avLst/>
+          </a:prstGeom>
+        </p:spPr>
+        <p:txBody>
+          <a:bodyPr anchor="t" rtlCol="false" tIns="0" lIns="0" bIns="0" rIns="0">
+            <a:spAutoFit/>
+          </a:bodyPr>
+          <a:lstStyle/>
+          <a:p>
+            <a:pPr algn="ctr">
+              <a:lnSpc>
+                <a:spcPts val="3960"/>
+              </a:lnSpc>
+              <a:spcBef>
+                <a:spcPct val="0"/>
+              </a:spcBef>
+            </a:pPr>
+            <a:r>
+              <a:rPr lang="en-US" b="true" sz="3300">
+                <a:solidFill>
+                  <a:srgbClr val="FFFFFF"/>
+                </a:solidFill>
+                <a:latin typeface="Arial Bold"/>
+                <a:ea typeface="Arial Bold"/>
+                <a:cs typeface="Arial Bold"/>
+                <a:sym typeface="Arial Bold"/>
+              </a:rPr>
+              <a:t>09</a:t>
             </a:r>
           </a:p>
         </p:txBody>

</xml_diff>

<commit_message>
Clearer UI: light/dark theme, plain labels, guided demo; new screenshots, deck, docs, pitch copy
Co-Authored-By: Claude Opus 5.5 <noreply@anthropic.com>
</commit_message>
<xml_diff>
--- a/docs/RootCause-ASYNC26-Final.pptx
+++ b/docs/RootCause-ASYNC26-Final.pptx
@@ -17288,7 +17288,7 @@
         </p:nvSpPr>
         <p:spPr>
           <a:xfrm>
-            <a:off x="2123895" y="3615538"/>
+            <a:off x="2147816" y="3675339"/>
             <a:ext cx="512064" cy="512064"/>
           </a:xfrm>
           <a:prstGeom prst="ellipse">
@@ -17312,7 +17312,7 @@
         </p:nvSpPr>
         <p:spPr>
           <a:xfrm>
-            <a:off x="2169615" y="3661258"/>
+            <a:off x="2193536" y="3721059"/>
             <a:ext cx="420624" cy="420624"/>
           </a:xfrm>
           <a:prstGeom prst="ellipse">
@@ -17336,7 +17336,7 @@
         </p:nvSpPr>
         <p:spPr>
           <a:xfrm>
-            <a:off x="2169615" y="3745382"/>
+            <a:off x="2193536" y="3805184"/>
             <a:ext cx="420624" cy="252374"/>
           </a:xfrm>
           <a:prstGeom prst="rect">
@@ -17382,7 +17382,7 @@
         </p:nvSpPr>
         <p:spPr>
           <a:xfrm>
-            <a:off x="6190415" y="4488643"/>
+            <a:off x="5933267" y="4751771"/>
             <a:ext cx="512064" cy="512064"/>
           </a:xfrm>
           <a:prstGeom prst="ellipse">
@@ -17406,7 +17406,7 @@
         </p:nvSpPr>
         <p:spPr>
           <a:xfrm>
-            <a:off x="6236135" y="4534363"/>
+            <a:off x="5978987" y="4797491"/>
             <a:ext cx="420624" cy="420624"/>
           </a:xfrm>
           <a:prstGeom prst="ellipse">
@@ -17430,7 +17430,7 @@
         </p:nvSpPr>
         <p:spPr>
           <a:xfrm>
-            <a:off x="6236135" y="4618488"/>
+            <a:off x="5978987" y="4881616"/>
             <a:ext cx="420624" cy="252374"/>
           </a:xfrm>
           <a:prstGeom prst="rect">
@@ -17476,7 +17476,7 @@
         </p:nvSpPr>
         <p:spPr>
           <a:xfrm>
-            <a:off x="2321241" y="5571055"/>
+            <a:off x="2291340" y="5768401"/>
             <a:ext cx="512064" cy="512064"/>
           </a:xfrm>
           <a:prstGeom prst="ellipse">
@@ -17500,7 +17500,7 @@
         </p:nvSpPr>
         <p:spPr>
           <a:xfrm>
-            <a:off x="2366961" y="5616775"/>
+            <a:off x="2337060" y="5814121"/>
             <a:ext cx="420624" cy="420624"/>
           </a:xfrm>
           <a:prstGeom prst="ellipse">
@@ -17524,7 +17524,7 @@
         </p:nvSpPr>
         <p:spPr>
           <a:xfrm>
-            <a:off x="2366961" y="5700900"/>
+            <a:off x="2337060" y="5898246"/>
             <a:ext cx="420624" cy="252374"/>
           </a:xfrm>
           <a:prstGeom prst="rect">
@@ -17570,7 +17570,7 @@
         </p:nvSpPr>
         <p:spPr>
           <a:xfrm>
-            <a:off x="7015679" y="5230185"/>
+            <a:off x="9760580" y="4721870"/>
             <a:ext cx="512064" cy="512064"/>
           </a:xfrm>
           <a:prstGeom prst="ellipse">
@@ -17594,7 +17594,7 @@
         </p:nvSpPr>
         <p:spPr>
           <a:xfrm>
-            <a:off x="7061399" y="5275905"/>
+            <a:off x="9806300" y="4767590"/>
             <a:ext cx="420624" cy="420624"/>
           </a:xfrm>
           <a:prstGeom prst="ellipse">
@@ -17618,7 +17618,7 @@
         </p:nvSpPr>
         <p:spPr>
           <a:xfrm>
-            <a:off x="7061399" y="5360030"/>
+            <a:off x="9806300" y="4851715"/>
             <a:ext cx="420624" cy="252374"/>
           </a:xfrm>
           <a:prstGeom prst="rect">
@@ -17839,7 +17839,7 @@
                 <a:cs typeface="Arimo"/>
                 <a:sym typeface="Arimo"/>
               </a:rPr>
-              <a:t xml:space="preserve">Documents, incidents, clusters, fixes that didn't hold, and external connections, which stays at zero.</a:t>
+              <a:t xml:space="preserve">Incidents in memory, recurring problems, fixes that didn't hold, and data sent outside, which stays at zero.</a:t>
             </a:r>
           </a:p>
         </p:txBody>
@@ -19214,7 +19214,7 @@
                 <a:cs typeface="Arimo"/>
                 <a:sym typeface="Arimo"/>
               </a:rPr>
-              <a:t xml:space="preserve">   ·   similarity, confidence, judge</a:t>
+              <a:t xml:space="preserve">   ·   evidence for every link</a:t>
             </a:r>
           </a:p>
         </p:txBody>
@@ -19697,8 +19697,8 @@
         </p:blipFill>
         <p:spPr>
           <a:xfrm>
-            <a:off x="1972313" y="3913632"/>
-            <a:ext cx="5793734" cy="2084832"/>
+            <a:off x="2013184" y="3913632"/>
+            <a:ext cx="5711991" cy="2084832"/>
           </a:xfrm>
           <a:prstGeom prst="rect">
             <a:avLst/>
@@ -19721,8 +19721,8 @@
         </p:blipFill>
         <p:spPr>
           <a:xfrm>
-            <a:off x="10569550" y="3913632"/>
-            <a:ext cx="5698541" cy="2084832"/>
+            <a:off x="9760635" y="3913632"/>
+            <a:ext cx="7316370" cy="2084832"/>
           </a:xfrm>
           <a:prstGeom prst="rect">
             <a:avLst/>
@@ -19745,8 +19745,8 @@
         </p:blipFill>
         <p:spPr>
           <a:xfrm>
-            <a:off x="961609" y="7040880"/>
-            <a:ext cx="7815142" cy="2084832"/>
+            <a:off x="2347453" y="7040880"/>
+            <a:ext cx="5043454" cy="2084832"/>
           </a:xfrm>
           <a:prstGeom prst="rect">
             <a:avLst/>
@@ -19769,8 +19769,8 @@
         </p:blipFill>
         <p:spPr>
           <a:xfrm>
-            <a:off x="10338528" y="7040880"/>
-            <a:ext cx="6160585" cy="2084832"/>
+            <a:off x="10734242" y="7040880"/>
+            <a:ext cx="5369156" cy="2084832"/>
           </a:xfrm>
           <a:prstGeom prst="rect">
             <a:avLst/>

</xml_diff>

<commit_message>
Updated deck + demo script; deck: 17 tests, model swap and scale test done
Co-Authored-By: Claude Opus 5.5 <noreply@anthropic.com>
</commit_message>
<xml_diff>
--- a/docs/RootCause-ASYNC26-Final.pptx
+++ b/docs/RootCause-ASYNC26-Final.pptx
@@ -4186,7 +4186,7 @@
                 <a:cs typeface="Arimo"/>
                 <a:sym typeface="Arimo"/>
               </a:rPr>
-              <a:t xml:space="preserve">   ·   working prototype, 13 automated tests</a:t>
+              <a:t xml:space="preserve">   ·   working prototype, 17 automated tests</a:t>
             </a:r>
           </a:p>
         </p:txBody>
@@ -12572,7 +12572,7 @@
                 <a:cs typeface="Arimo"/>
                 <a:sym typeface="Arimo"/>
               </a:rPr>
-              <a:t xml:space="preserve">Built and working: one RTX 3050 laptop, no internet, 13 automated tests passing.</a:t>
+              <a:t xml:space="preserve">Built and working: one RTX 3050 laptop, no internet, 17 automated tests passing.</a:t>
             </a:r>
           </a:p>
         </p:txBody>
@@ -16168,7 +16168,7 @@
                 <a:cs typeface="Arimo"/>
                 <a:sym typeface="Arimo"/>
               </a:rPr>
-              <a:t xml:space="preserve">Click WHY —</a:t>
+              <a:t xml:space="preserve">Why linked? —</a:t>
             </a:r>
           </a:p>
           <a:p>
@@ -16191,7 +16191,7 @@
                 <a:cs typeface="Arimo"/>
                 <a:sym typeface="Arimo"/>
               </a:rPr>
-              <a:t xml:space="preserve">3 incidents, 7 chunks</a:t>
+              <a:t xml:space="preserve">evidence per link</a:t>
             </a:r>
           </a:p>
         </p:txBody>
@@ -20422,7 +20422,7 @@
         </p:nvSpPr>
         <p:spPr>
           <a:xfrm>
-            <a:off x="1161288" y="3853688"/>
+            <a:off x="1161288" y="3709035"/>
             <a:ext cx="530352" cy="530352"/>
           </a:xfrm>
           <a:prstGeom prst="ellipse">
@@ -20446,7 +20446,7 @@
         </p:nvSpPr>
         <p:spPr>
           <a:xfrm>
-            <a:off x="1161288" y="3970365"/>
+            <a:off x="1161288" y="3825712"/>
             <a:ext cx="530352" cy="318211"/>
           </a:xfrm>
           <a:prstGeom prst="rect">
@@ -20492,7 +20492,7 @@
         </p:nvSpPr>
         <p:spPr>
           <a:xfrm>
-            <a:off x="1892808" y="3956812"/>
+            <a:off x="1892808" y="3812159"/>
             <a:ext cx="3834384" cy="324104"/>
           </a:xfrm>
           <a:prstGeom prst="rect">
@@ -20538,8 +20538,8 @@
         </p:nvSpPr>
         <p:spPr>
           <a:xfrm>
-            <a:off x="1161288" y="4603496"/>
-            <a:ext cx="4565904" cy="2547112"/>
+            <a:off x="1161288" y="4458843"/>
+            <a:ext cx="4565904" cy="2691765"/>
           </a:xfrm>
           <a:prstGeom prst="rect">
             <a:avLst/>
@@ -20571,7 +20571,7 @@
                 <a:cs typeface="Arimo"/>
                 <a:sym typeface="Arimo"/>
               </a:rPr>
-              <a:t xml:space="preserve">Vault ingestion with a live watcher · hybrid retrieval with citations · centroid recurrence clustering · WHY evidence view · fix effectiveness · falsifiable predictions · failure debt · pre-flight check · injection quarantine · policy gate + MCP · Obsidian write-back · hash-chained audit · egress monitor · offline fallback.</a:t>
+              <a:t xml:space="preserve">Vault ingestion with a live watcher · hybrid retrieval with citations · centroid recurrence clustering · WHY evidence view · fix effectiveness · falsifiable predictions · failure debt · pre-flight check · injection quarantine · policy gate + MCP · Obsidian write-back · hash-chained audit · egress monitor · offline fallback · live model swap · 500-incident scale test.</a:t>
             </a:r>
           </a:p>
         </p:txBody>
@@ -20610,7 +20610,7 @@
         </p:nvSpPr>
         <p:spPr>
           <a:xfrm>
-            <a:off x="6861048" y="3853688"/>
+            <a:off x="6861048" y="3709035"/>
             <a:ext cx="530352" cy="530352"/>
           </a:xfrm>
           <a:prstGeom prst="ellipse">
@@ -20634,7 +20634,7 @@
         </p:nvSpPr>
         <p:spPr>
           <a:xfrm>
-            <a:off x="6861048" y="3970365"/>
+            <a:off x="6861048" y="3825712"/>
             <a:ext cx="530352" cy="318211"/>
           </a:xfrm>
           <a:prstGeom prst="rect">
@@ -20680,7 +20680,7 @@
         </p:nvSpPr>
         <p:spPr>
           <a:xfrm>
-            <a:off x="7592568" y="3956812"/>
+            <a:off x="7592568" y="3812159"/>
             <a:ext cx="3834384" cy="324104"/>
           </a:xfrm>
           <a:prstGeom prst="rect">
@@ -20726,8 +20726,8 @@
         </p:nvSpPr>
         <p:spPr>
           <a:xfrm>
-            <a:off x="6861048" y="4603496"/>
-            <a:ext cx="4565904" cy="2547112"/>
+            <a:off x="6861048" y="4458843"/>
+            <a:ext cx="4565904" cy="2691765"/>
           </a:xfrm>
           <a:prstGeom prst="rect">
             <a:avLst/>
@@ -20798,7 +20798,7 @@
         </p:nvSpPr>
         <p:spPr>
           <a:xfrm>
-            <a:off x="12560808" y="3853688"/>
+            <a:off x="12560808" y="3709035"/>
             <a:ext cx="530352" cy="530352"/>
           </a:xfrm>
           <a:prstGeom prst="ellipse">
@@ -20822,7 +20822,7 @@
         </p:nvSpPr>
         <p:spPr>
           <a:xfrm>
-            <a:off x="12560808" y="3970365"/>
+            <a:off x="12560808" y="3825712"/>
             <a:ext cx="530352" cy="318211"/>
           </a:xfrm>
           <a:prstGeom prst="rect">
@@ -20868,7 +20868,7 @@
         </p:nvSpPr>
         <p:spPr>
           <a:xfrm>
-            <a:off x="13292328" y="3956812"/>
+            <a:off x="13292328" y="3812159"/>
             <a:ext cx="3834384" cy="324104"/>
           </a:xfrm>
           <a:prstGeom prst="rect">
@@ -20914,8 +20914,8 @@
         </p:nvSpPr>
         <p:spPr>
           <a:xfrm>
-            <a:off x="12560808" y="4603496"/>
-            <a:ext cx="4565904" cy="2547112"/>
+            <a:off x="12560808" y="4458843"/>
+            <a:ext cx="4565904" cy="2691765"/>
           </a:xfrm>
           <a:prstGeom prst="rect">
             <a:avLst/>
@@ -20947,7 +20947,7 @@
                 <a:cs typeface="Arimo"/>
                 <a:sym typeface="Arimo"/>
               </a:rPr>
-              <a:t xml:space="preserve">Tune thresholds on the RTX 3050 with Llama 3.2 3B · measure the &lt; 5 s answer target · model-swap demo, Llama ↔ Qwen on the same memory · PostgreSQL + pgvector behind the same interface · Jira and ServiceNow connectors after the hackathon.</a:t>
+              <a:t xml:space="preserve">Tune thresholds on the RTX 3050 with Llama 3.2 3B · measure the &lt; 5 s answer target · scale test with the model judge on the GPU · Jira / ServiceNow importer · PostgreSQL + pgvector behind the same interface.</a:t>
             </a:r>
           </a:p>
         </p:txBody>
@@ -21031,7 +21031,7 @@
                 <a:cs typeface="Arimo"/>
                 <a:sym typeface="Arimo"/>
               </a:rPr>
-              <a:t xml:space="preserve">github.com/BradCage-afk/root-cause   ·   setup.bat → run.bat on Windows   ·   python -m pytest runs 13 end-to-end tests</a:t>
+              <a:t xml:space="preserve">github.com/BradCage-afk/root-cause   ·   setup.bat → run.bat on Windows   ·   python -m pytest runs 17 end-to-end tests</a:t>
             </a:r>
           </a:p>
         </p:txBody>

</xml_diff>